<commit_message>
Fix deployed presentation job and average check
</commit_message>
<xml_diff>
--- a/Шаблон презентации новый.pptx
+++ b/Шаблон презентации новый.pptx
@@ -6688,7 +6688,7 @@
         </p:nvSpPr>
         <p:spPr>
           <a:xfrm>
-            <a:off x="5335422" y="3798693"/>
+            <a:off x="5346700" y="3705225"/>
             <a:ext cx="2065020" cy="1756891"/>
           </a:xfrm>
           <a:prstGeom prst="rect">
@@ -6855,56 +6855,46 @@
                 <a:latin typeface="Century Gothic"/>
                 <a:cs typeface="Century Gothic"/>
               </a:rPr>
-              <a:t>{{</a:t>
-            </a:r>
-            <a:r>
-              <a:rPr lang="en-US" sz="3600" spc="-382" baseline="-5787" dirty="0" smtClean="0">
+              <a:t>{{block11}}</a:t>
+            </a:r>
+            <a:r>
+              <a:rPr sz="3600" spc="-397" baseline="-5787" dirty="0" smtClean="0">
                 <a:solidFill>
                   <a:srgbClr val="245BA9"/>
                 </a:solidFill>
                 <a:latin typeface="Century Gothic"/>
                 <a:cs typeface="Century Gothic"/>
               </a:rPr>
-              <a:t>block11}}</a:t>
-            </a:r>
-            <a:r>
-              <a:rPr sz="3600" spc="-397" baseline="-5787" dirty="0" smtClean="0">
+              <a:t> </a:t>
+            </a:r>
+            <a:r>
+              <a:rPr lang="ru-RU" sz="1200" spc="-397" baseline="-5787" dirty="0" smtClean="0">
                 <a:solidFill>
                   <a:srgbClr val="245BA9"/>
                 </a:solidFill>
                 <a:latin typeface="Century Gothic"/>
                 <a:cs typeface="Century Gothic"/>
               </a:rPr>
-              <a:t> </a:t>
-            </a:r>
-            <a:r>
-              <a:rPr lang="ru-RU" sz="3600" spc="-397" baseline="-5787" dirty="0" smtClean="0">
+              <a:t/>
+            </a:r>
+            <a:br>
+              <a:rPr lang="ru-RU" sz="1200" spc="-397" baseline="-5787" dirty="0" smtClean="0">
                 <a:solidFill>
                   <a:srgbClr val="245BA9"/>
                 </a:solidFill>
                 <a:latin typeface="Century Gothic"/>
                 <a:cs typeface="Century Gothic"/>
               </a:rPr>
-              <a:t/>
-            </a:r>
-            <a:br>
-              <a:rPr lang="ru-RU" sz="3600" spc="-397" baseline="-5787" dirty="0" smtClean="0">
+            </a:br>
+            <a:r>
+              <a:rPr lang="ru-RU" sz="1200" spc="-397" baseline="-5787" dirty="0" smtClean="0">
                 <a:solidFill>
                   <a:srgbClr val="245BA9"/>
                 </a:solidFill>
                 <a:latin typeface="Century Gothic"/>
                 <a:cs typeface="Century Gothic"/>
               </a:rPr>
-            </a:br>
-            <a:r>
-              <a:rPr lang="ru-RU" sz="1200" spc="-397" baseline="-5787" dirty="0" smtClean="0">
-                <a:solidFill>
-                  <a:srgbClr val="245BA9"/>
-                </a:solidFill>
-                <a:latin typeface="Century Gothic"/>
-                <a:cs typeface="Century Gothic"/>
-              </a:rPr>
-              <a:t> </a:t>
+              <a:t>  </a:t>
             </a:r>
             <a:r>
               <a:rPr lang="ru-RU" sz="1200" dirty="0">

</xml_diff>

<commit_message>
Add PDF presentation upload and block31 mapping
</commit_message>
<xml_diff>
--- a/Шаблон презентации новый.pptx
+++ b/Шаблон презентации новый.pptx
@@ -170,7 +170,7 @@
             <a:fld id="{1D8BD707-D9CF-40AE-B4C6-C98DA3205C09}" type="datetimeFigureOut">
               <a:rPr lang="en-US"/>
               <a:pPr/>
-              <a:t>6/25/2026</a:t>
+              <a:t>6/26/2026</a:t>
             </a:fld>
             <a:endParaRPr lang="en-US"/>
           </a:p>
@@ -360,7 +360,7 @@
             <a:fld id="{1D8BD707-D9CF-40AE-B4C6-C98DA3205C09}" type="datetimeFigureOut">
               <a:rPr lang="en-US"/>
               <a:pPr/>
-              <a:t>6/25/2026</a:t>
+              <a:t>6/26/2026</a:t>
             </a:fld>
             <a:endParaRPr lang="en-US"/>
           </a:p>
@@ -733,7 +733,7 @@
             <a:fld id="{1D8BD707-D9CF-40AE-B4C6-C98DA3205C09}" type="datetimeFigureOut">
               <a:rPr lang="en-US"/>
               <a:pPr/>
-              <a:t>6/25/2026</a:t>
+              <a:t>6/26/2026</a:t>
             </a:fld>
             <a:endParaRPr lang="en-US"/>
           </a:p>
@@ -900,7 +900,7 @@
             <a:fld id="{1D8BD707-D9CF-40AE-B4C6-C98DA3205C09}" type="datetimeFigureOut">
               <a:rPr lang="en-US"/>
               <a:pPr/>
-              <a:t>6/25/2026</a:t>
+              <a:t>6/26/2026</a:t>
             </a:fld>
             <a:endParaRPr lang="en-US"/>
           </a:p>
@@ -1279,7 +1279,7 @@
             <a:fld id="{1D8BD707-D9CF-40AE-B4C6-C98DA3205C09}" type="datetimeFigureOut">
               <a:rPr lang="en-US"/>
               <a:pPr/>
-              <a:t>6/25/2026</a:t>
+              <a:t>6/26/2026</a:t>
             </a:fld>
             <a:endParaRPr lang="en-US"/>
           </a:p>
@@ -1539,7 +1539,7 @@
             <a:fld id="{1D8BD707-D9CF-40AE-B4C6-C98DA3205C09}" type="datetimeFigureOut">
               <a:rPr lang="en-US"/>
               <a:pPr/>
-              <a:t>6/25/2026</a:t>
+              <a:t>6/26/2026</a:t>
             </a:fld>
             <a:endParaRPr lang="en-US"/>
           </a:p>
@@ -2300,8 +2300,8 @@
         </p:nvSpPr>
         <p:spPr>
           <a:xfrm>
-            <a:off x="546100" y="1876425"/>
-            <a:ext cx="2560320" cy="182101"/>
+            <a:off x="546100" y="1724025"/>
+            <a:ext cx="9601200" cy="182101"/>
           </a:xfrm>
           <a:prstGeom prst="rect">
             <a:avLst/>
@@ -2346,7 +2346,7 @@
         </p:nvSpPr>
         <p:spPr>
           <a:xfrm>
-            <a:off x="546100" y="2257425"/>
+            <a:off x="546100" y="1952625"/>
             <a:ext cx="9556115" cy="450764"/>
           </a:xfrm>
           <a:prstGeom prst="rect">
@@ -3034,7 +3034,7 @@
         <p:spPr>
           <a:xfrm>
             <a:off x="3596830" y="6718655"/>
-            <a:ext cx="4899660" cy="284480"/>
+            <a:ext cx="5102670" cy="274434"/>
           </a:xfrm>
           <a:prstGeom prst="rect">
             <a:avLst/>
@@ -3055,6 +3055,26 @@
               </a:spcBef>
             </a:pPr>
             <a:r>
+              <a:rPr lang="ru-RU" sz="1700" dirty="0" smtClean="0">
+                <a:solidFill>
+                  <a:srgbClr val="FFFFFF"/>
+                </a:solidFill>
+                <a:latin typeface="Century Gothic"/>
+                <a:cs typeface="Century Gothic"/>
+              </a:rPr>
+              <a:t>15</a:t>
+            </a:r>
+            <a:r>
+              <a:rPr sz="1700" spc="-35" dirty="0" smtClean="0">
+                <a:solidFill>
+                  <a:srgbClr val="FFFFFF"/>
+                </a:solidFill>
+                <a:latin typeface="Century Gothic"/>
+                <a:cs typeface="Century Gothic"/>
+              </a:rPr>
+              <a:t> </a:t>
+            </a:r>
+            <a:r>
               <a:rPr sz="1700" dirty="0">
                 <a:solidFill>
                   <a:srgbClr val="FFFFFF"/>
@@ -3062,7 +3082,7 @@
                 <a:latin typeface="Century Gothic"/>
                 <a:cs typeface="Century Gothic"/>
               </a:rPr>
-              <a:t>10</a:t>
+              <a:t>и</a:t>
             </a:r>
             <a:r>
               <a:rPr sz="1700" spc="-35" dirty="0">
@@ -3075,6 +3095,56 @@
               <a:t> </a:t>
             </a:r>
             <a:r>
+              <a:rPr sz="1700" dirty="0" smtClean="0">
+                <a:solidFill>
+                  <a:srgbClr val="FFFFFF"/>
+                </a:solidFill>
+                <a:latin typeface="Century Gothic"/>
+                <a:cs typeface="Century Gothic"/>
+              </a:rPr>
+              <a:t>1</a:t>
+            </a:r>
+            <a:r>
+              <a:rPr lang="ru-RU" sz="1700" dirty="0" smtClean="0">
+                <a:solidFill>
+                  <a:srgbClr val="FFFFFF"/>
+                </a:solidFill>
+                <a:latin typeface="Century Gothic"/>
+                <a:cs typeface="Century Gothic"/>
+              </a:rPr>
+              <a:t>6</a:t>
+            </a:r>
+            <a:r>
+              <a:rPr sz="1700" spc="-30" dirty="0" smtClean="0">
+                <a:solidFill>
+                  <a:srgbClr val="FFFFFF"/>
+                </a:solidFill>
+                <a:latin typeface="Century Gothic"/>
+                <a:cs typeface="Century Gothic"/>
+              </a:rPr>
+              <a:t> </a:t>
+            </a:r>
+            <a:r>
+              <a:rPr lang="ru-RU" sz="1700" spc="-30" dirty="0" smtClean="0">
+                <a:solidFill>
+                  <a:srgbClr val="FFFFFF"/>
+                </a:solidFill>
+                <a:latin typeface="Century Gothic"/>
+                <a:cs typeface="Century Gothic"/>
+              </a:rPr>
+              <a:t>сентября</a:t>
+            </a:r>
+            <a:r>
+              <a:rPr sz="1700" spc="-35" dirty="0" smtClean="0">
+                <a:solidFill>
+                  <a:srgbClr val="FFFFFF"/>
+                </a:solidFill>
+                <a:latin typeface="Century Gothic"/>
+                <a:cs typeface="Century Gothic"/>
+              </a:rPr>
+              <a:t> </a:t>
+            </a:r>
+            <a:r>
               <a:rPr sz="1700" dirty="0">
                 <a:solidFill>
                   <a:srgbClr val="FFFFFF"/>
@@ -3082,7 +3152,7 @@
                 <a:latin typeface="Century Gothic"/>
                 <a:cs typeface="Century Gothic"/>
               </a:rPr>
-              <a:t>и</a:t>
+              <a:t>2026,</a:t>
             </a:r>
             <a:r>
               <a:rPr sz="1700" spc="-35" dirty="0">
@@ -3102,7 +3172,7 @@
                 <a:latin typeface="Century Gothic"/>
                 <a:cs typeface="Century Gothic"/>
               </a:rPr>
-              <a:t>11</a:t>
+              <a:t>Москва,</a:t>
             </a:r>
             <a:r>
               <a:rPr sz="1700" spc="-30" dirty="0">
@@ -3115,6 +3185,16 @@
               <a:t> </a:t>
             </a:r>
             <a:r>
+              <a:rPr sz="1700" dirty="0">
+                <a:solidFill>
+                  <a:srgbClr val="FFFFFF"/>
+                </a:solidFill>
+                <a:latin typeface="Century Gothic"/>
+                <a:cs typeface="Century Gothic"/>
+              </a:rPr>
+              <a:t>Крокус</a:t>
+            </a:r>
+            <a:r>
               <a:rPr sz="1700" spc="-35" dirty="0">
                 <a:solidFill>
                   <a:srgbClr val="FFFFFF"/>
@@ -3122,79 +3202,19 @@
                 <a:latin typeface="Century Gothic"/>
                 <a:cs typeface="Century Gothic"/>
               </a:rPr>
-              <a:t>февраля </a:t>
-            </a:r>
-            <a:r>
-              <a:rPr sz="1700" dirty="0">
+              <a:t> </a:t>
+            </a:r>
+            <a:r>
+              <a:rPr sz="1700" spc="-10" dirty="0">
                 <a:solidFill>
                   <a:srgbClr val="FFFFFF"/>
                 </a:solidFill>
                 <a:latin typeface="Century Gothic"/>
                 <a:cs typeface="Century Gothic"/>
               </a:rPr>
-              <a:t>2026,</a:t>
-            </a:r>
-            <a:r>
-              <a:rPr sz="1700" spc="-35" dirty="0">
-                <a:solidFill>
-                  <a:srgbClr val="FFFFFF"/>
-                </a:solidFill>
-                <a:latin typeface="Century Gothic"/>
-                <a:cs typeface="Century Gothic"/>
-              </a:rPr>
-              <a:t> </a:t>
-            </a:r>
-            <a:r>
-              <a:rPr sz="1700" dirty="0">
-                <a:solidFill>
-                  <a:srgbClr val="FFFFFF"/>
-                </a:solidFill>
-                <a:latin typeface="Century Gothic"/>
-                <a:cs typeface="Century Gothic"/>
-              </a:rPr>
-              <a:t>Москва,</a:t>
-            </a:r>
-            <a:r>
-              <a:rPr sz="1700" spc="-30" dirty="0">
-                <a:solidFill>
-                  <a:srgbClr val="FFFFFF"/>
-                </a:solidFill>
-                <a:latin typeface="Century Gothic"/>
-                <a:cs typeface="Century Gothic"/>
-              </a:rPr>
-              <a:t> </a:t>
-            </a:r>
-            <a:r>
-              <a:rPr sz="1700" dirty="0">
-                <a:solidFill>
-                  <a:srgbClr val="FFFFFF"/>
-                </a:solidFill>
-                <a:latin typeface="Century Gothic"/>
-                <a:cs typeface="Century Gothic"/>
-              </a:rPr>
-              <a:t>Крокус</a:t>
-            </a:r>
-            <a:r>
-              <a:rPr sz="1700" spc="-35" dirty="0">
-                <a:solidFill>
-                  <a:srgbClr val="FFFFFF"/>
-                </a:solidFill>
-                <a:latin typeface="Century Gothic"/>
-                <a:cs typeface="Century Gothic"/>
-              </a:rPr>
-              <a:t> </a:t>
-            </a:r>
-            <a:r>
-              <a:rPr sz="1700" spc="-10" dirty="0">
-                <a:solidFill>
-                  <a:srgbClr val="FFFFFF"/>
-                </a:solidFill>
-                <a:latin typeface="Century Gothic"/>
-                <a:cs typeface="Century Gothic"/>
-              </a:rPr>
               <a:t>Экспо</a:t>
             </a:r>
-            <a:endParaRPr sz="1700">
+            <a:endParaRPr sz="1700" dirty="0">
               <a:latin typeface="Century Gothic"/>
               <a:cs typeface="Century Gothic"/>
             </a:endParaRPr>
@@ -6776,167 +6796,180 @@
                 <a:latin typeface="Century Gothic"/>
                 <a:cs typeface="Century Gothic"/>
               </a:rPr>
-              <a:t>   </a:t>
+              <a:t> </a:t>
+            </a:r>
+            <a:r>
+              <a:rPr lang="ru-RU" sz="1200" spc="-25" dirty="0" smtClean="0">
+                <a:solidFill>
+                  <a:schemeClr val="tx1"/>
+                </a:solidFill>
+                <a:latin typeface="Century Gothic"/>
+                <a:cs typeface="Century Gothic"/>
+              </a:rPr>
+              <a:t>Ф</a:t>
+            </a:r>
+            <a:r>
+              <a:rPr sz="1200" spc="-25" dirty="0" err="1" smtClean="0">
+                <a:solidFill>
+                  <a:schemeClr val="tx1"/>
+                </a:solidFill>
+                <a:latin typeface="Century Gothic"/>
+                <a:cs typeface="Century Gothic"/>
+              </a:rPr>
+              <a:t>едеральных</a:t>
+            </a:r>
+            <a:r>
+              <a:rPr sz="1200" spc="5" dirty="0" smtClean="0">
+                <a:solidFill>
+                  <a:schemeClr val="tx1"/>
+                </a:solidFill>
+                <a:latin typeface="Century Gothic"/>
+                <a:cs typeface="Century Gothic"/>
+              </a:rPr>
+              <a:t> </a:t>
+            </a:r>
+            <a:r>
+              <a:rPr sz="1200" spc="-10" dirty="0" err="1" smtClean="0">
+                <a:solidFill>
+                  <a:schemeClr val="tx1"/>
+                </a:solidFill>
+                <a:latin typeface="Century Gothic"/>
+                <a:cs typeface="Century Gothic"/>
+              </a:rPr>
+              <a:t>Сетей</a:t>
+            </a:r>
+            <a:r>
+              <a:rPr lang="ru-RU" sz="1200" spc="-10" dirty="0" smtClean="0">
+                <a:solidFill>
+                  <a:schemeClr val="tx1"/>
+                </a:solidFill>
+                <a:latin typeface="Century Gothic"/>
+                <a:cs typeface="Century Gothic"/>
+              </a:rPr>
+              <a:t> </a:t>
+            </a:r>
+            <a:r>
+              <a:rPr lang="ru-RU" sz="1200" spc="-10" dirty="0" smtClean="0">
+                <a:solidFill>
+                  <a:schemeClr val="tx1"/>
+                </a:solidFill>
+                <a:latin typeface="Century Gothic"/>
+                <a:cs typeface="Century Gothic"/>
+              </a:rPr>
+              <a:t/>
             </a:r>
             <a:br>
-              <a:rPr lang="ru-RU" sz="3600" spc="-382" baseline="-5787" dirty="0" smtClean="0">
+              <a:rPr lang="ru-RU" sz="1200" spc="-10" dirty="0" smtClean="0">
+                <a:solidFill>
+                  <a:schemeClr val="tx1"/>
+                </a:solidFill>
+                <a:latin typeface="Century Gothic"/>
+                <a:cs typeface="Century Gothic"/>
+              </a:rPr>
+            </a:br>
+            <a:r>
+              <a:rPr lang="ru-RU" sz="800" spc="-10" dirty="0" smtClean="0">
+                <a:solidFill>
+                  <a:schemeClr val="tx1"/>
+                </a:solidFill>
+                <a:latin typeface="Century Gothic"/>
+                <a:cs typeface="Century Gothic"/>
+              </a:rPr>
+              <a:t/>
+            </a:r>
+            <a:br>
+              <a:rPr lang="ru-RU" sz="800" spc="-10" dirty="0" smtClean="0">
+                <a:solidFill>
+                  <a:schemeClr val="tx1"/>
+                </a:solidFill>
+                <a:latin typeface="Century Gothic"/>
+                <a:cs typeface="Century Gothic"/>
+              </a:rPr>
+            </a:br>
+            <a:r>
+              <a:rPr lang="en-US" sz="3600" spc="-382" baseline="-5787" dirty="0" smtClean="0">
                 <a:solidFill>
                   <a:srgbClr val="245BA9"/>
                 </a:solidFill>
                 <a:latin typeface="Century Gothic"/>
                 <a:cs typeface="Century Gothic"/>
               </a:rPr>
-            </a:br>
-            <a:r>
-              <a:rPr lang="ru-RU" sz="3600" spc="-382" baseline="-5787" dirty="0" smtClean="0">
+              <a:t>{{</a:t>
+            </a:r>
+            <a:r>
+              <a:rPr lang="en-US" sz="3600" spc="-382" baseline="-5787" dirty="0" smtClean="0">
                 <a:solidFill>
                   <a:srgbClr val="245BA9"/>
                 </a:solidFill>
                 <a:latin typeface="Century Gothic"/>
                 <a:cs typeface="Century Gothic"/>
               </a:rPr>
-              <a:t> </a:t>
-            </a:r>
-            <a:r>
-              <a:rPr lang="ru-RU" sz="1200" spc="-25" dirty="0" smtClean="0">
+              <a:t>block11}}</a:t>
+            </a:r>
+            <a:r>
+              <a:rPr sz="3600" spc="-397" baseline="-5787" dirty="0" smtClean="0">
                 <a:solidFill>
                   <a:srgbClr val="245BA9"/>
                 </a:solidFill>
                 <a:latin typeface="Century Gothic"/>
                 <a:cs typeface="Century Gothic"/>
               </a:rPr>
-              <a:t>Ф</a:t>
-            </a:r>
-            <a:r>
-              <a:rPr sz="1200" spc="-25" dirty="0" err="1" smtClean="0">
-                <a:solidFill>
-                  <a:srgbClr val="245BA9"/>
-                </a:solidFill>
-                <a:latin typeface="Century Gothic"/>
-                <a:cs typeface="Century Gothic"/>
-              </a:rPr>
-              <a:t>едеральных</a:t>
-            </a:r>
-            <a:r>
-              <a:rPr sz="1200" spc="5" dirty="0" smtClean="0">
-                <a:solidFill>
-                  <a:srgbClr val="245BA9"/>
-                </a:solidFill>
-                <a:latin typeface="Century Gothic"/>
-                <a:cs typeface="Century Gothic"/>
-              </a:rPr>
-              <a:t> </a:t>
-            </a:r>
-            <a:r>
-              <a:rPr sz="1200" spc="-10" dirty="0" err="1" smtClean="0">
-                <a:solidFill>
-                  <a:srgbClr val="245BA9"/>
+              <a:t> </a:t>
+            </a:r>
+            <a:r>
+              <a:rPr lang="ru-RU" sz="1200" spc="-397" baseline="-5787" dirty="0" smtClean="0">
+                <a:solidFill>
+                  <a:schemeClr val="tx1"/>
+                </a:solidFill>
+                <a:latin typeface="Century Gothic"/>
+                <a:cs typeface="Century Gothic"/>
+              </a:rPr>
+              <a:t>  </a:t>
+            </a:r>
+            <a:r>
+              <a:rPr lang="ru-RU" sz="1200" dirty="0">
+                <a:solidFill>
+                  <a:schemeClr val="tx1"/>
+                </a:solidFill>
+                <a:latin typeface="Century Gothic"/>
+                <a:cs typeface="Century Gothic"/>
+              </a:rPr>
+              <a:t>Р</a:t>
+            </a:r>
+            <a:r>
+              <a:rPr sz="1200" dirty="0" err="1" smtClean="0">
+                <a:solidFill>
+                  <a:schemeClr val="tx1"/>
+                </a:solidFill>
+                <a:latin typeface="Century Gothic"/>
+                <a:cs typeface="Century Gothic"/>
+              </a:rPr>
+              <a:t>егиональных</a:t>
+            </a:r>
+            <a:r>
+              <a:rPr sz="1200" dirty="0" smtClean="0">
+                <a:solidFill>
+                  <a:schemeClr val="tx1"/>
+                </a:solidFill>
+                <a:latin typeface="Century Gothic"/>
+                <a:cs typeface="Century Gothic"/>
+              </a:rPr>
+              <a:t> </a:t>
+            </a:r>
+            <a:r>
+              <a:rPr sz="1200" spc="-10" dirty="0">
+                <a:solidFill>
+                  <a:schemeClr val="tx1"/>
                 </a:solidFill>
                 <a:latin typeface="Century Gothic"/>
                 <a:cs typeface="Century Gothic"/>
               </a:rPr>
               <a:t>Сетей</a:t>
             </a:r>
-            <a:r>
-              <a:rPr lang="ru-RU" sz="1200" spc="-10" dirty="0" smtClean="0">
-                <a:solidFill>
-                  <a:srgbClr val="245BA9"/>
-                </a:solidFill>
-                <a:latin typeface="Century Gothic"/>
-                <a:cs typeface="Century Gothic"/>
-              </a:rPr>
-              <a:t> </a:t>
-            </a:r>
-            <a:r>
-              <a:rPr lang="en-US" sz="3600" spc="-382" baseline="-5787" dirty="0" smtClean="0">
-                <a:solidFill>
-                  <a:srgbClr val="245BA9"/>
-                </a:solidFill>
-                <a:latin typeface="Century Gothic"/>
-                <a:cs typeface="Century Gothic"/>
-              </a:rPr>
-              <a:t>{{block11}}</a:t>
-            </a:r>
-            <a:r>
-              <a:rPr sz="3600" spc="-397" baseline="-5787" dirty="0" smtClean="0">
-                <a:solidFill>
-                  <a:srgbClr val="245BA9"/>
-                </a:solidFill>
-                <a:latin typeface="Century Gothic"/>
-                <a:cs typeface="Century Gothic"/>
-              </a:rPr>
-              <a:t> </a:t>
-            </a:r>
-            <a:r>
-              <a:rPr lang="ru-RU" sz="1200" spc="-397" baseline="-5787" dirty="0" smtClean="0">
-                <a:solidFill>
-                  <a:srgbClr val="245BA9"/>
-                </a:solidFill>
-                <a:latin typeface="Century Gothic"/>
-                <a:cs typeface="Century Gothic"/>
-              </a:rPr>
-              <a:t/>
-            </a:r>
-            <a:br>
-              <a:rPr lang="ru-RU" sz="1200" spc="-397" baseline="-5787" dirty="0" smtClean="0">
-                <a:solidFill>
-                  <a:srgbClr val="245BA9"/>
-                </a:solidFill>
-                <a:latin typeface="Century Gothic"/>
-                <a:cs typeface="Century Gothic"/>
-              </a:rPr>
-            </a:br>
-            <a:r>
-              <a:rPr lang="ru-RU" sz="1200" spc="-397" baseline="-5787" dirty="0" smtClean="0">
-                <a:solidFill>
-                  <a:srgbClr val="245BA9"/>
-                </a:solidFill>
-                <a:latin typeface="Century Gothic"/>
-                <a:cs typeface="Century Gothic"/>
-              </a:rPr>
-              <a:t>  </a:t>
-            </a:r>
-            <a:r>
-              <a:rPr lang="ru-RU" sz="1200" dirty="0">
-                <a:solidFill>
-                  <a:srgbClr val="245BA9"/>
-                </a:solidFill>
-                <a:latin typeface="Century Gothic"/>
-                <a:cs typeface="Century Gothic"/>
-              </a:rPr>
-              <a:t>Р</a:t>
-            </a:r>
-            <a:r>
-              <a:rPr sz="1200" dirty="0" err="1" smtClean="0">
-                <a:solidFill>
-                  <a:srgbClr val="245BA9"/>
-                </a:solidFill>
-                <a:latin typeface="Century Gothic"/>
-                <a:cs typeface="Century Gothic"/>
-              </a:rPr>
-              <a:t>егиональных</a:t>
-            </a:r>
-            <a:r>
-              <a:rPr sz="1200" dirty="0" smtClean="0">
-                <a:solidFill>
-                  <a:srgbClr val="245BA9"/>
-                </a:solidFill>
-                <a:latin typeface="Century Gothic"/>
-                <a:cs typeface="Century Gothic"/>
-              </a:rPr>
-              <a:t> </a:t>
-            </a:r>
-            <a:r>
-              <a:rPr sz="1200" spc="-10" dirty="0">
-                <a:solidFill>
-                  <a:srgbClr val="245BA9"/>
-                </a:solidFill>
-                <a:latin typeface="Century Gothic"/>
-                <a:cs typeface="Century Gothic"/>
-              </a:rPr>
-              <a:t>Сетей</a:t>
-            </a:r>
             <a:endParaRPr sz="1200" dirty="0">
+              <a:solidFill>
+                <a:schemeClr val="tx1"/>
+              </a:solidFill>
               <a:latin typeface="Century Gothic"/>
               <a:cs typeface="Century Gothic"/>
             </a:endParaRPr>
@@ -6951,7 +6984,7 @@
         </p:nvSpPr>
         <p:spPr>
           <a:xfrm>
-            <a:off x="7682624" y="4137342"/>
+            <a:off x="7556500" y="4010025"/>
             <a:ext cx="2617076" cy="1321067"/>
           </a:xfrm>
           <a:prstGeom prst="rect">
@@ -6995,7 +7028,7 @@
             <a:r>
               <a:rPr lang="ru-RU" sz="1200" dirty="0">
                 <a:solidFill>
-                  <a:srgbClr val="245BA9"/>
+                  <a:schemeClr val="tx1"/>
                 </a:solidFill>
                 <a:latin typeface="Century Gothic"/>
                 <a:cs typeface="Century Gothic"/>
@@ -7005,7 +7038,7 @@
             <a:r>
               <a:rPr sz="1200" dirty="0" err="1" smtClean="0">
                 <a:solidFill>
-                  <a:srgbClr val="245BA9"/>
+                  <a:schemeClr val="tx1"/>
                 </a:solidFill>
                 <a:latin typeface="Century Gothic"/>
                 <a:cs typeface="Century Gothic"/>
@@ -7015,7 +7048,7 @@
             <a:r>
               <a:rPr sz="1200" spc="30" dirty="0" smtClean="0">
                 <a:solidFill>
-                  <a:srgbClr val="245BA9"/>
+                  <a:schemeClr val="tx1"/>
                 </a:solidFill>
                 <a:latin typeface="Century Gothic"/>
                 <a:cs typeface="Century Gothic"/>
@@ -7025,7 +7058,7 @@
             <a:r>
               <a:rPr sz="1200" spc="-10" dirty="0">
                 <a:solidFill>
-                  <a:srgbClr val="245BA9"/>
+                  <a:schemeClr val="tx1"/>
                 </a:solidFill>
                 <a:latin typeface="Century Gothic"/>
                 <a:cs typeface="Century Gothic"/>
@@ -7033,6 +7066,9 @@
               <a:t>Сетей</a:t>
             </a:r>
             <a:endParaRPr sz="1200" dirty="0">
+              <a:solidFill>
+                <a:schemeClr val="tx1"/>
+              </a:solidFill>
               <a:latin typeface="Century Gothic"/>
               <a:cs typeface="Century Gothic"/>
             </a:endParaRPr>
@@ -7079,7 +7115,7 @@
             <a:r>
               <a:rPr lang="ru-RU" sz="1200" spc="-10" dirty="0" smtClean="0">
                 <a:solidFill>
-                  <a:srgbClr val="245BA9"/>
+                  <a:schemeClr val="tx1"/>
                 </a:solidFill>
                 <a:latin typeface="Century Gothic"/>
                 <a:cs typeface="Century Gothic"/>
@@ -7089,7 +7125,7 @@
             <a:r>
               <a:rPr lang="en-US" sz="1200" spc="-10" dirty="0" err="1" smtClean="0">
                 <a:solidFill>
-                  <a:srgbClr val="245BA9"/>
+                  <a:schemeClr val="tx1"/>
                 </a:solidFill>
                 <a:latin typeface="Century Gothic"/>
                 <a:cs typeface="Century Gothic"/>
@@ -7099,7 +7135,7 @@
             <a:r>
               <a:rPr sz="1200" spc="-10" dirty="0" err="1" smtClean="0">
                 <a:solidFill>
-                  <a:srgbClr val="245BA9"/>
+                  <a:schemeClr val="tx1"/>
                 </a:solidFill>
                 <a:latin typeface="Century Gothic"/>
                 <a:cs typeface="Century Gothic"/>
@@ -7107,6 +7143,9 @@
               <a:t>oReCa</a:t>
             </a:r>
             <a:endParaRPr sz="1200" dirty="0">
+              <a:solidFill>
+                <a:schemeClr val="tx1"/>
+              </a:solidFill>
               <a:latin typeface="Century Gothic"/>
               <a:cs typeface="Century Gothic"/>
             </a:endParaRPr>
@@ -7491,7 +7530,7 @@
         </p:nvSpPr>
         <p:spPr>
           <a:xfrm>
-            <a:off x="5803900" y="1800225"/>
+            <a:off x="5727700" y="1800225"/>
             <a:ext cx="2971800" cy="874983"/>
           </a:xfrm>
           <a:prstGeom prst="rect">
@@ -7731,27 +7770,7 @@
                 <a:latin typeface="Century Gothic"/>
                 <a:cs typeface="Century Gothic"/>
               </a:rPr>
-              <a:t>{{block</a:t>
-            </a:r>
-            <a:r>
-              <a:rPr lang="ru-RU" sz="3600" spc="-25" dirty="0" smtClean="0">
-                <a:solidFill>
-                  <a:srgbClr val="245BA9"/>
-                </a:solidFill>
-                <a:latin typeface="Century Gothic"/>
-                <a:cs typeface="Century Gothic"/>
-              </a:rPr>
-              <a:t>27</a:t>
-            </a:r>
-            <a:r>
-              <a:rPr lang="en-US" sz="3600" spc="-25" dirty="0" smtClean="0">
-                <a:solidFill>
-                  <a:srgbClr val="245BA9"/>
-                </a:solidFill>
-                <a:latin typeface="Century Gothic"/>
-                <a:cs typeface="Century Gothic"/>
-              </a:rPr>
-              <a:t>}}</a:t>
+              <a:t>{{block31}}</a:t>
             </a:r>
             <a:r>
               <a:rPr sz="1100" dirty="0">
@@ -11018,7 +11037,7 @@
         <p:spPr>
           <a:xfrm>
             <a:off x="3587305" y="813282"/>
-            <a:ext cx="1169035" cy="1146175"/>
+            <a:ext cx="1683195" cy="1188146"/>
           </a:xfrm>
           <a:prstGeom prst="rect">
             <a:avLst/>
@@ -11038,7 +11057,7 @@
                 <a:spcPts val="745"/>
               </a:spcBef>
             </a:pPr>
-            <a:endParaRPr sz="1400">
+            <a:endParaRPr sz="1400" dirty="0">
               <a:latin typeface="Times New Roman"/>
               <a:cs typeface="Times New Roman"/>
             </a:endParaRPr>
@@ -11069,17 +11088,7 @@
               </a:rPr>
               <a:t> </a:t>
             </a:r>
-            <a:r>
-              <a:rPr sz="1400" spc="-20" dirty="0">
-                <a:solidFill>
-                  <a:srgbClr val="245BA9"/>
-                </a:solidFill>
-                <a:latin typeface="Century Gothic"/>
-                <a:cs typeface="Century Gothic"/>
-              </a:rPr>
-              <a:t>года</a:t>
-            </a:r>
-            <a:endParaRPr sz="1400">
+            <a:endParaRPr sz="1400" dirty="0">
               <a:latin typeface="Century Gothic"/>
               <a:cs typeface="Century Gothic"/>
             </a:endParaRPr>
@@ -11094,27 +11103,41 @@
               </a:spcBef>
             </a:pPr>
             <a:r>
-              <a:rPr sz="1000" dirty="0">
+              <a:rPr lang="ru-RU" sz="1200" dirty="0">
+                <a:latin typeface="Century Gothic"/>
+                <a:cs typeface="Century Gothic"/>
+              </a:rPr>
+              <a:t>л</a:t>
+            </a:r>
+            <a:r>
+              <a:rPr lang="ru-RU" sz="1200" dirty="0" smtClean="0">
+                <a:latin typeface="Century Gothic"/>
+                <a:cs typeface="Century Gothic"/>
+              </a:rPr>
+              <a:t>ет </a:t>
+            </a:r>
+            <a:r>
+              <a:rPr sz="1200" dirty="0" err="1" smtClean="0">
                 <a:latin typeface="Century Gothic"/>
                 <a:cs typeface="Century Gothic"/>
               </a:rPr>
               <a:t>работы</a:t>
             </a:r>
             <a:r>
-              <a:rPr sz="1000" spc="-40" dirty="0">
-                <a:latin typeface="Century Gothic"/>
-                <a:cs typeface="Century Gothic"/>
-              </a:rPr>
-              <a:t> </a:t>
-            </a:r>
-            <a:r>
-              <a:rPr sz="1000" spc="-20" dirty="0">
+              <a:rPr sz="1200" spc="-40" dirty="0" smtClean="0">
+                <a:latin typeface="Century Gothic"/>
+                <a:cs typeface="Century Gothic"/>
+              </a:rPr>
+              <a:t> </a:t>
+            </a:r>
+            <a:r>
+              <a:rPr sz="1200" spc="-20" dirty="0">
                 <a:latin typeface="Century Gothic"/>
                 <a:cs typeface="Century Gothic"/>
               </a:rPr>
               <a:t>компании</a:t>
             </a:r>
-            <a:endParaRPr sz="1000">
+            <a:endParaRPr sz="1200" dirty="0">
               <a:latin typeface="Century Gothic"/>
               <a:cs typeface="Century Gothic"/>
             </a:endParaRPr>
@@ -11242,7 +11265,7 @@
         <p:spPr>
           <a:xfrm>
             <a:off x="7187298" y="813282"/>
-            <a:ext cx="3341002" cy="926536"/>
+            <a:ext cx="3341002" cy="1542089"/>
           </a:xfrm>
           <a:prstGeom prst="rect">
             <a:avLst/>
@@ -11268,20 +11291,37 @@
             </a:endParaRPr>
           </a:p>
           <a:p>
+            <a:pPr marL="12700"/>
+            <a:r>
+              <a:rPr lang="en-US" sz="4000" dirty="0" smtClean="0">
+                <a:solidFill>
+                  <a:srgbClr val="245BA9"/>
+                </a:solidFill>
+                <a:latin typeface="Century Gothic"/>
+                <a:cs typeface="Century Gothic"/>
+              </a:rPr>
+              <a:t>{{block14}}</a:t>
+            </a:r>
+            <a:endParaRPr lang="ru-RU" sz="1400" dirty="0" smtClean="0">
+              <a:latin typeface="Century Gothic"/>
+              <a:cs typeface="Century Gothic"/>
+            </a:endParaRPr>
+          </a:p>
+          <a:p>
             <a:pPr marL="12700">
               <a:lnSpc>
                 <a:spcPct val="100000"/>
               </a:lnSpc>
             </a:pPr>
             <a:r>
-              <a:rPr lang="en-US" sz="4000" dirty="0" smtClean="0">
+              <a:rPr lang="ru-RU" sz="4000" dirty="0" smtClean="0">
                 <a:solidFill>
                   <a:srgbClr val="245BA9"/>
                 </a:solidFill>
                 <a:latin typeface="Century Gothic"/>
                 <a:cs typeface="Century Gothic"/>
               </a:rPr>
-              <a:t>{{block14}}</a:t>
+              <a:t>  </a:t>
             </a:r>
             <a:endParaRPr sz="1000" dirty="0">
               <a:latin typeface="Century Gothic"/>
@@ -11298,7 +11338,7 @@
         </p:nvSpPr>
         <p:spPr>
           <a:xfrm>
-            <a:off x="7251700" y="2028825"/>
+            <a:off x="7251700" y="1876425"/>
             <a:ext cx="3251200" cy="1146175"/>
           </a:xfrm>
           <a:prstGeom prst="rect">
@@ -12532,7 +12572,7 @@
         <p:spPr>
           <a:xfrm>
             <a:off x="7251700" y="1724025"/>
-            <a:ext cx="2438400" cy="738664"/>
+            <a:ext cx="2438400" cy="461665"/>
           </a:xfrm>
           <a:prstGeom prst="rect">
             <a:avLst/>
@@ -12548,67 +12588,53 @@
               <a:lnSpc>
                 <a:spcPct val="100000"/>
               </a:lnSpc>
-            </a:pPr>
-            <a:r>
-              <a:rPr lang="ru-RU" sz="1600" spc="-10" dirty="0" smtClean="0">
-                <a:solidFill>
-                  <a:srgbClr val="245BA9"/>
-                </a:solidFill>
-                <a:latin typeface="Century Gothic"/>
-                <a:cs typeface="Century Gothic"/>
-              </a:rPr>
-              <a:t>контрактов</a:t>
-            </a:r>
-            <a:endParaRPr lang="ru-RU" sz="1600" dirty="0" smtClean="0">
-              <a:latin typeface="Century Gothic"/>
-              <a:cs typeface="Century Gothic"/>
-            </a:endParaRPr>
-          </a:p>
-          <a:p>
-            <a:pPr marL="12700">
-              <a:lnSpc>
-                <a:spcPct val="100000"/>
-              </a:lnSpc>
               <a:spcBef>
                 <a:spcPts val="565"/>
               </a:spcBef>
             </a:pPr>
             <a:r>
-              <a:rPr lang="ru-RU" sz="1050" dirty="0" smtClean="0">
-                <a:latin typeface="Century Gothic"/>
-                <a:cs typeface="Century Gothic"/>
-              </a:rPr>
-              <a:t>заключено</a:t>
-            </a:r>
-            <a:r>
-              <a:rPr lang="ru-RU" sz="1050" spc="55" dirty="0" smtClean="0">
+              <a:rPr lang="ru-RU" sz="1200" dirty="0">
+                <a:latin typeface="Century Gothic"/>
+                <a:cs typeface="Century Gothic"/>
+              </a:rPr>
+              <a:t>к</a:t>
+            </a:r>
+            <a:r>
+              <a:rPr lang="ru-RU" sz="1200" dirty="0" smtClean="0">
+                <a:latin typeface="Century Gothic"/>
+                <a:cs typeface="Century Gothic"/>
+              </a:rPr>
+              <a:t>онтрактов заключено</a:t>
+            </a:r>
+            <a:r>
+              <a:rPr lang="ru-RU" sz="1200" spc="55" dirty="0" smtClean="0">
                 <a:latin typeface="Century Gothic"/>
                 <a:cs typeface="Century Gothic"/>
               </a:rPr>
               <a:t> всего </a:t>
             </a:r>
             <a:r>
-              <a:rPr lang="ru-RU" sz="1050" spc="65" dirty="0" smtClean="0">
+              <a:rPr lang="ru-RU" sz="1200" spc="65" dirty="0" smtClean="0">
                 <a:latin typeface="Century Gothic"/>
                 <a:cs typeface="Century Gothic"/>
               </a:rPr>
               <a:t>в вашей</a:t>
             </a:r>
             <a:r>
-              <a:rPr lang="ru-RU" sz="1050" spc="55" dirty="0" smtClean="0">
-                <a:latin typeface="Century Gothic"/>
-                <a:cs typeface="Century Gothic"/>
-              </a:rPr>
-              <a:t> </a:t>
-            </a:r>
-            <a:r>
-              <a:rPr lang="ru-RU" sz="1050" spc="-10" dirty="0" smtClean="0">
+              <a:rPr lang="ru-RU" sz="1200" spc="55" dirty="0" smtClean="0">
+                <a:latin typeface="Century Gothic"/>
+                <a:cs typeface="Century Gothic"/>
+              </a:rPr>
+              <a:t> </a:t>
+            </a:r>
+            <a:r>
+              <a:rPr lang="ru-RU" sz="1200" spc="-10" dirty="0" smtClean="0">
                 <a:latin typeface="Century Gothic"/>
                 <a:cs typeface="Century Gothic"/>
               </a:rPr>
               <a:t>категории</a:t>
             </a:r>
-            <a:endParaRPr lang="ru-RU" sz="1050" dirty="0" smtClean="0">
+            <a:endParaRPr lang="ru-RU" sz="1200" dirty="0" smtClean="0">
               <a:latin typeface="Century Gothic"/>
               <a:cs typeface="Century Gothic"/>
             </a:endParaRPr>

</xml_diff>

<commit_message>
Update presentation template file
</commit_message>
<xml_diff>
--- a/Шаблон презентации новый.pptx
+++ b/Шаблон презентации новый.pptx
@@ -170,7 +170,7 @@
             <a:fld id="{1D8BD707-D9CF-40AE-B4C6-C98DA3205C09}" type="datetimeFigureOut">
               <a:rPr lang="en-US"/>
               <a:pPr/>
-              <a:t>6/26/2026</a:t>
+              <a:t>7/29/2026</a:t>
             </a:fld>
             <a:endParaRPr lang="en-US"/>
           </a:p>
@@ -360,7 +360,7 @@
             <a:fld id="{1D8BD707-D9CF-40AE-B4C6-C98DA3205C09}" type="datetimeFigureOut">
               <a:rPr lang="en-US"/>
               <a:pPr/>
-              <a:t>6/26/2026</a:t>
+              <a:t>7/29/2026</a:t>
             </a:fld>
             <a:endParaRPr lang="en-US"/>
           </a:p>
@@ -733,7 +733,7 @@
             <a:fld id="{1D8BD707-D9CF-40AE-B4C6-C98DA3205C09}" type="datetimeFigureOut">
               <a:rPr lang="en-US"/>
               <a:pPr/>
-              <a:t>6/26/2026</a:t>
+              <a:t>7/29/2026</a:t>
             </a:fld>
             <a:endParaRPr lang="en-US"/>
           </a:p>
@@ -900,7 +900,7 @@
             <a:fld id="{1D8BD707-D9CF-40AE-B4C6-C98DA3205C09}" type="datetimeFigureOut">
               <a:rPr lang="en-US"/>
               <a:pPr/>
-              <a:t>6/26/2026</a:t>
+              <a:t>7/29/2026</a:t>
             </a:fld>
             <a:endParaRPr lang="en-US"/>
           </a:p>
@@ -1279,7 +1279,7 @@
             <a:fld id="{1D8BD707-D9CF-40AE-B4C6-C98DA3205C09}" type="datetimeFigureOut">
               <a:rPr lang="en-US"/>
               <a:pPr/>
-              <a:t>6/26/2026</a:t>
+              <a:t>7/29/2026</a:t>
             </a:fld>
             <a:endParaRPr lang="en-US"/>
           </a:p>
@@ -1539,7 +1539,7 @@
             <a:fld id="{1D8BD707-D9CF-40AE-B4C6-C98DA3205C09}" type="datetimeFigureOut">
               <a:rPr lang="en-US"/>
               <a:pPr/>
-              <a:t>6/26/2026</a:t>
+              <a:t>7/29/2026</a:t>
             </a:fld>
             <a:endParaRPr lang="en-US"/>
           </a:p>
@@ -2758,7 +2758,7 @@
         <p:spPr>
           <a:xfrm>
             <a:off x="3596830" y="6090285"/>
-            <a:ext cx="3242310" cy="238760"/>
+            <a:ext cx="3242310" cy="228268"/>
           </a:xfrm>
           <a:prstGeom prst="rect">
             <a:avLst/>
@@ -3999,193 +3999,156 @@
           </a:p>
         </p:txBody>
       </p:sp>
-      <p:grpSp>
-        <p:nvGrpSpPr>
-          <p:cNvPr id="4" name="object 4"/>
-          <p:cNvGrpSpPr/>
+      <p:sp>
+        <p:nvSpPr>
+          <p:cNvPr id="5" name="object 5"/>
+          <p:cNvSpPr/>
           <p:nvPr/>
-        </p:nvGrpSpPr>
-        <p:grpSpPr>
+        </p:nvSpPr>
+        <p:spPr>
           <a:xfrm>
-            <a:off x="359994" y="4658995"/>
-            <a:ext cx="9360535" cy="2385060"/>
-            <a:chOff x="359994" y="4658995"/>
-            <a:chExt cx="9360535" cy="2385060"/>
+            <a:off x="364756" y="6688785"/>
+            <a:ext cx="802005" cy="350520"/>
           </a:xfrm>
-        </p:grpSpPr>
-        <p:sp>
-          <p:nvSpPr>
-            <p:cNvPr id="5" name="object 5"/>
-            <p:cNvSpPr/>
-            <p:nvPr/>
-          </p:nvSpPr>
-          <p:spPr>
-            <a:xfrm>
-              <a:off x="364756" y="6688785"/>
-              <a:ext cx="802005" cy="350520"/>
-            </a:xfrm>
-            <a:custGeom>
-              <a:avLst/>
-              <a:gdLst/>
-              <a:ahLst/>
-              <a:cxnLst/>
-              <a:rect l="l" t="t" r="r" b="b"/>
-              <a:pathLst>
-                <a:path w="802005" h="350520">
-                  <a:moveTo>
-                    <a:pt x="750214" y="51320"/>
-                  </a:moveTo>
-                  <a:lnTo>
-                    <a:pt x="708907" y="20691"/>
-                  </a:lnTo>
-                  <a:lnTo>
-                    <a:pt x="660493" y="3376"/>
-                  </a:lnTo>
-                  <a:lnTo>
-                    <a:pt x="626313" y="0"/>
-                  </a:lnTo>
-                  <a:lnTo>
-                    <a:pt x="175221" y="0"/>
-                  </a:lnTo>
-                  <a:lnTo>
-                    <a:pt x="124360" y="7549"/>
-                  </a:lnTo>
-                  <a:lnTo>
-                    <a:pt x="77881" y="29537"/>
-                  </a:lnTo>
-                  <a:lnTo>
-                    <a:pt x="64065" y="39777"/>
-                  </a:lnTo>
-                  <a:lnTo>
-                    <a:pt x="51320" y="51320"/>
-                  </a:lnTo>
-                </a:path>
-                <a:path w="802005" h="350520">
-                  <a:moveTo>
-                    <a:pt x="51320" y="299161"/>
-                  </a:moveTo>
-                  <a:lnTo>
-                    <a:pt x="92627" y="329779"/>
-                  </a:lnTo>
-                  <a:lnTo>
-                    <a:pt x="141041" y="347092"/>
-                  </a:lnTo>
-                  <a:lnTo>
-                    <a:pt x="175221" y="350469"/>
-                  </a:lnTo>
-                  <a:lnTo>
-                    <a:pt x="621550" y="350469"/>
-                  </a:lnTo>
-                  <a:lnTo>
-                    <a:pt x="659898" y="347092"/>
-                  </a:lnTo>
-                  <a:lnTo>
-                    <a:pt x="708907" y="329779"/>
-                  </a:lnTo>
-                  <a:lnTo>
-                    <a:pt x="737469" y="310702"/>
-                  </a:lnTo>
-                  <a:lnTo>
-                    <a:pt x="750214" y="299161"/>
-                  </a:lnTo>
-                </a:path>
-                <a:path w="802005" h="350520">
-                  <a:moveTo>
-                    <a:pt x="51320" y="51320"/>
-                  </a:moveTo>
-                  <a:lnTo>
-                    <a:pt x="20702" y="92627"/>
-                  </a:lnTo>
-                  <a:lnTo>
-                    <a:pt x="3382" y="141041"/>
-                  </a:lnTo>
-                  <a:lnTo>
-                    <a:pt x="0" y="175221"/>
-                  </a:lnTo>
-                  <a:lnTo>
-                    <a:pt x="0" y="170497"/>
-                  </a:lnTo>
-                  <a:lnTo>
-                    <a:pt x="3382" y="208843"/>
-                  </a:lnTo>
-                  <a:lnTo>
-                    <a:pt x="20702" y="257847"/>
-                  </a:lnTo>
-                  <a:lnTo>
-                    <a:pt x="39779" y="286410"/>
-                  </a:lnTo>
-                  <a:lnTo>
-                    <a:pt x="51320" y="299161"/>
-                  </a:lnTo>
-                </a:path>
-                <a:path w="802005" h="350520">
-                  <a:moveTo>
-                    <a:pt x="750214" y="299161"/>
-                  </a:moveTo>
-                  <a:lnTo>
-                    <a:pt x="780832" y="257847"/>
-                  </a:lnTo>
-                  <a:lnTo>
-                    <a:pt x="798156" y="209438"/>
-                  </a:lnTo>
-                  <a:lnTo>
-                    <a:pt x="801535" y="175260"/>
-                  </a:lnTo>
-                  <a:lnTo>
-                    <a:pt x="801535" y="179984"/>
-                  </a:lnTo>
-                  <a:lnTo>
-                    <a:pt x="798156" y="141636"/>
-                  </a:lnTo>
-                  <a:lnTo>
-                    <a:pt x="780832" y="92627"/>
-                  </a:lnTo>
-                  <a:lnTo>
-                    <a:pt x="761755" y="64065"/>
-                  </a:lnTo>
-                  <a:lnTo>
-                    <a:pt x="750214" y="51320"/>
-                  </a:lnTo>
-                </a:path>
-              </a:pathLst>
-            </a:custGeom>
-            <a:ln w="9525">
-              <a:solidFill>
-                <a:srgbClr val="9CC9ED"/>
-              </a:solidFill>
-            </a:ln>
-          </p:spPr>
-          <p:txBody>
-            <a:bodyPr wrap="square" lIns="0" tIns="0" rIns="0" bIns="0" rtlCol="0"/>
-            <a:lstStyle/>
-            <a:p>
-              <a:endParaRPr/>
-            </a:p>
-          </p:txBody>
-        </p:sp>
-        <p:pic>
-          <p:nvPicPr>
-            <p:cNvPr id="6" name="object 6"/>
-            <p:cNvPicPr/>
-            <p:nvPr/>
-          </p:nvPicPr>
-          <p:blipFill>
-            <a:blip r:embed="rId2" cstate="print"/>
-            <a:stretch>
-              <a:fillRect/>
-            </a:stretch>
-          </p:blipFill>
-          <p:spPr>
-            <a:xfrm>
-              <a:off x="7919999" y="4658995"/>
-              <a:ext cx="1799996" cy="1799996"/>
-            </a:xfrm>
-            <a:prstGeom prst="rect">
-              <a:avLst/>
-            </a:prstGeom>
-          </p:spPr>
-        </p:pic>
-      </p:grpSp>
+          <a:custGeom>
+            <a:avLst/>
+            <a:gdLst/>
+            <a:ahLst/>
+            <a:cxnLst/>
+            <a:rect l="l" t="t" r="r" b="b"/>
+            <a:pathLst>
+              <a:path w="802005" h="350520">
+                <a:moveTo>
+                  <a:pt x="750214" y="51320"/>
+                </a:moveTo>
+                <a:lnTo>
+                  <a:pt x="708907" y="20691"/>
+                </a:lnTo>
+                <a:lnTo>
+                  <a:pt x="660493" y="3376"/>
+                </a:lnTo>
+                <a:lnTo>
+                  <a:pt x="626313" y="0"/>
+                </a:lnTo>
+                <a:lnTo>
+                  <a:pt x="175221" y="0"/>
+                </a:lnTo>
+                <a:lnTo>
+                  <a:pt x="124360" y="7549"/>
+                </a:lnTo>
+                <a:lnTo>
+                  <a:pt x="77881" y="29537"/>
+                </a:lnTo>
+                <a:lnTo>
+                  <a:pt x="64065" y="39777"/>
+                </a:lnTo>
+                <a:lnTo>
+                  <a:pt x="51320" y="51320"/>
+                </a:lnTo>
+              </a:path>
+              <a:path w="802005" h="350520">
+                <a:moveTo>
+                  <a:pt x="51320" y="299161"/>
+                </a:moveTo>
+                <a:lnTo>
+                  <a:pt x="92627" y="329779"/>
+                </a:lnTo>
+                <a:lnTo>
+                  <a:pt x="141041" y="347092"/>
+                </a:lnTo>
+                <a:lnTo>
+                  <a:pt x="175221" y="350469"/>
+                </a:lnTo>
+                <a:lnTo>
+                  <a:pt x="621550" y="350469"/>
+                </a:lnTo>
+                <a:lnTo>
+                  <a:pt x="659898" y="347092"/>
+                </a:lnTo>
+                <a:lnTo>
+                  <a:pt x="708907" y="329779"/>
+                </a:lnTo>
+                <a:lnTo>
+                  <a:pt x="737469" y="310702"/>
+                </a:lnTo>
+                <a:lnTo>
+                  <a:pt x="750214" y="299161"/>
+                </a:lnTo>
+              </a:path>
+              <a:path w="802005" h="350520">
+                <a:moveTo>
+                  <a:pt x="51320" y="51320"/>
+                </a:moveTo>
+                <a:lnTo>
+                  <a:pt x="20702" y="92627"/>
+                </a:lnTo>
+                <a:lnTo>
+                  <a:pt x="3382" y="141041"/>
+                </a:lnTo>
+                <a:lnTo>
+                  <a:pt x="0" y="175221"/>
+                </a:lnTo>
+                <a:lnTo>
+                  <a:pt x="0" y="170497"/>
+                </a:lnTo>
+                <a:lnTo>
+                  <a:pt x="3382" y="208843"/>
+                </a:lnTo>
+                <a:lnTo>
+                  <a:pt x="20702" y="257847"/>
+                </a:lnTo>
+                <a:lnTo>
+                  <a:pt x="39779" y="286410"/>
+                </a:lnTo>
+                <a:lnTo>
+                  <a:pt x="51320" y="299161"/>
+                </a:lnTo>
+              </a:path>
+              <a:path w="802005" h="350520">
+                <a:moveTo>
+                  <a:pt x="750214" y="299161"/>
+                </a:moveTo>
+                <a:lnTo>
+                  <a:pt x="780832" y="257847"/>
+                </a:lnTo>
+                <a:lnTo>
+                  <a:pt x="798156" y="209438"/>
+                </a:lnTo>
+                <a:lnTo>
+                  <a:pt x="801535" y="175260"/>
+                </a:lnTo>
+                <a:lnTo>
+                  <a:pt x="801535" y="179984"/>
+                </a:lnTo>
+                <a:lnTo>
+                  <a:pt x="798156" y="141636"/>
+                </a:lnTo>
+                <a:lnTo>
+                  <a:pt x="780832" y="92627"/>
+                </a:lnTo>
+                <a:lnTo>
+                  <a:pt x="761755" y="64065"/>
+                </a:lnTo>
+                <a:lnTo>
+                  <a:pt x="750214" y="51320"/>
+                </a:lnTo>
+              </a:path>
+            </a:pathLst>
+          </a:custGeom>
+          <a:ln w="9525">
+            <a:solidFill>
+              <a:srgbClr val="9CC9ED"/>
+            </a:solidFill>
+          </a:ln>
+        </p:spPr>
+        <p:txBody>
+          <a:bodyPr wrap="square" lIns="0" tIns="0" rIns="0" bIns="0" rtlCol="0"/>
+          <a:lstStyle/>
+          <a:p>
+            <a:endParaRPr/>
+          </a:p>
+        </p:txBody>
+      </p:sp>
       <p:sp>
         <p:nvSpPr>
           <p:cNvPr id="7" name="object 7"/>
@@ -5353,7 +5316,7 @@
                 </a:uFill>
                 <a:latin typeface="Century Gothic"/>
                 <a:cs typeface="Century Gothic"/>
-                <a:hlinkClick r:id="rId3"/>
+                <a:hlinkClick r:id="rId2"/>
               </a:rPr>
               <a:t>ссылке</a:t>
             </a:r>
@@ -5430,6 +5393,99 @@
           </a:p>
         </p:txBody>
       </p:sp>
+      <p:sp>
+        <p:nvSpPr>
+          <p:cNvPr id="7170" name="AutoShape 2" descr="QR preview"/>
+          <p:cNvSpPr>
+            <a:spLocks noChangeAspect="1" noChangeArrowheads="1"/>
+          </p:cNvSpPr>
+          <p:nvPr/>
+        </p:nvSpPr>
+        <p:spPr bwMode="auto">
+          <a:xfrm>
+            <a:off x="155575" y="-144463"/>
+            <a:ext cx="304800" cy="304801"/>
+          </a:xfrm>
+          <a:prstGeom prst="rect">
+            <a:avLst/>
+          </a:prstGeom>
+          <a:noFill/>
+        </p:spPr>
+        <p:txBody>
+          <a:bodyPr vert="horz" wrap="square" lIns="91440" tIns="45720" rIns="91440" bIns="45720" numCol="1" anchor="t" anchorCtr="0" compatLnSpc="1">
+            <a:prstTxWarp prst="textNoShape">
+              <a:avLst/>
+            </a:prstTxWarp>
+          </a:bodyPr>
+          <a:lstStyle/>
+          <a:p>
+            <a:endParaRPr lang="ru-RU"/>
+          </a:p>
+        </p:txBody>
+      </p:sp>
+      <p:sp>
+        <p:nvSpPr>
+          <p:cNvPr id="7172" name="AutoShape 4" descr="QR preview"/>
+          <p:cNvSpPr>
+            <a:spLocks noChangeAspect="1" noChangeArrowheads="1"/>
+          </p:cNvSpPr>
+          <p:nvPr/>
+        </p:nvSpPr>
+        <p:spPr bwMode="auto">
+          <a:xfrm>
+            <a:off x="155575" y="-144463"/>
+            <a:ext cx="304800" cy="304801"/>
+          </a:xfrm>
+          <a:prstGeom prst="rect">
+            <a:avLst/>
+          </a:prstGeom>
+          <a:noFill/>
+        </p:spPr>
+        <p:txBody>
+          <a:bodyPr vert="horz" wrap="square" lIns="91440" tIns="45720" rIns="91440" bIns="45720" numCol="1" anchor="t" anchorCtr="0" compatLnSpc="1">
+            <a:prstTxWarp prst="textNoShape">
+              <a:avLst/>
+            </a:prstTxWarp>
+          </a:bodyPr>
+          <a:lstStyle/>
+          <a:p>
+            <a:endParaRPr lang="ru-RU"/>
+          </a:p>
+        </p:txBody>
+      </p:sp>
+      <p:pic>
+        <p:nvPicPr>
+          <p:cNvPr id="7173" name="Picture 5"/>
+          <p:cNvPicPr>
+            <a:picLocks noChangeAspect="1" noChangeArrowheads="1"/>
+          </p:cNvPicPr>
+          <p:nvPr/>
+        </p:nvPicPr>
+        <p:blipFill>
+          <a:blip r:embed="rId3" cstate="print"/>
+          <a:srcRect/>
+          <a:stretch>
+            <a:fillRect/>
+          </a:stretch>
+        </p:blipFill>
+        <p:spPr bwMode="auto">
+          <a:xfrm>
+            <a:off x="7937500" y="4467225"/>
+            <a:ext cx="1600200" cy="1577556"/>
+          </a:xfrm>
+          <a:prstGeom prst="rect">
+            <a:avLst/>
+          </a:prstGeom>
+          <a:noFill/>
+          <a:ln w="9525">
+            <a:noFill/>
+            <a:miter lim="800000"/>
+            <a:headEnd/>
+            <a:tailEnd/>
+          </a:ln>
+          <a:effectLst/>
+        </p:spPr>
+      </p:pic>
     </p:spTree>
   </p:cSld>
   <p:clrMapOvr>
@@ -6737,17 +6793,7 @@
                 <a:latin typeface="Century Gothic"/>
                 <a:cs typeface="Century Gothic"/>
               </a:rPr>
-              <a:t>{{</a:t>
-            </a:r>
-            <a:r>
-              <a:rPr lang="en-US" sz="3600" spc="-382" baseline="-5787" dirty="0" smtClean="0">
-                <a:solidFill>
-                  <a:srgbClr val="245BA9"/>
-                </a:solidFill>
-                <a:latin typeface="Century Gothic"/>
-                <a:cs typeface="Century Gothic"/>
-              </a:rPr>
-              <a:t>block10}} </a:t>
+              <a:t>{{block10}} </a:t>
             </a:r>
             <a:r>
               <a:rPr lang="en-US" sz="1200" spc="-382" baseline="-5787" dirty="0" smtClean="0">
@@ -7244,169 +7290,132 @@
           </a:p>
         </p:txBody>
       </p:sp>
-      <p:grpSp>
-        <p:nvGrpSpPr>
-          <p:cNvPr id="23" name="object 23"/>
-          <p:cNvGrpSpPr/>
+      <p:sp>
+        <p:nvSpPr>
+          <p:cNvPr id="25" name="object 25"/>
+          <p:cNvSpPr/>
           <p:nvPr/>
-        </p:nvGrpSpPr>
-        <p:grpSpPr>
+        </p:nvSpPr>
+        <p:spPr>
           <a:xfrm>
-            <a:off x="3600005" y="5638851"/>
-            <a:ext cx="6696075" cy="1365250"/>
-            <a:chOff x="3600005" y="5638851"/>
-            <a:chExt cx="6696075" cy="1365250"/>
+            <a:off x="3604767" y="5643613"/>
+            <a:ext cx="6686550" cy="1355725"/>
           </a:xfrm>
-        </p:grpSpPr>
-        <p:pic>
-          <p:nvPicPr>
-            <p:cNvPr id="24" name="object 24"/>
-            <p:cNvPicPr/>
-            <p:nvPr/>
-          </p:nvPicPr>
-          <p:blipFill>
-            <a:blip r:embed="rId7" cstate="print"/>
-            <a:stretch>
-              <a:fillRect/>
-            </a:stretch>
-          </p:blipFill>
-          <p:spPr>
-            <a:xfrm>
-              <a:off x="8793530" y="5792368"/>
-              <a:ext cx="899998" cy="899998"/>
-            </a:xfrm>
-            <a:prstGeom prst="rect">
-              <a:avLst/>
-            </a:prstGeom>
-          </p:spPr>
-        </p:pic>
-        <p:sp>
-          <p:nvSpPr>
-            <p:cNvPr id="25" name="object 25"/>
-            <p:cNvSpPr/>
-            <p:nvPr/>
-          </p:nvSpPr>
-          <p:spPr>
-            <a:xfrm>
-              <a:off x="3604767" y="5643613"/>
-              <a:ext cx="6686550" cy="1355725"/>
-            </a:xfrm>
-            <a:custGeom>
-              <a:avLst/>
-              <a:gdLst/>
-              <a:ahLst/>
-              <a:cxnLst/>
-              <a:rect l="l" t="t" r="r" b="b"/>
-              <a:pathLst>
-                <a:path w="6686550" h="1355725">
-                  <a:moveTo>
-                    <a:pt x="6666776" y="19685"/>
-                  </a:moveTo>
-                  <a:lnTo>
-                    <a:pt x="6632344" y="1292"/>
-                  </a:lnTo>
-                  <a:lnTo>
-                    <a:pt x="6619227" y="0"/>
-                  </a:lnTo>
-                  <a:lnTo>
-                    <a:pt x="67233" y="0"/>
-                  </a:lnTo>
-                  <a:lnTo>
-                    <a:pt x="29879" y="11329"/>
-                  </a:lnTo>
-                  <a:lnTo>
-                    <a:pt x="24576" y="15256"/>
-                  </a:lnTo>
-                  <a:lnTo>
-                    <a:pt x="19685" y="19685"/>
-                  </a:lnTo>
-                </a:path>
-                <a:path w="6686550" h="1355725">
-                  <a:moveTo>
-                    <a:pt x="19685" y="1335900"/>
-                  </a:moveTo>
-                  <a:lnTo>
-                    <a:pt x="54116" y="1354293"/>
-                  </a:lnTo>
-                  <a:lnTo>
-                    <a:pt x="67233" y="1355585"/>
-                  </a:lnTo>
-                  <a:lnTo>
-                    <a:pt x="6614464" y="1355585"/>
-                  </a:lnTo>
-                  <a:lnTo>
-                    <a:pt x="6656585" y="1344255"/>
-                  </a:lnTo>
-                  <a:lnTo>
-                    <a:pt x="6661886" y="1340328"/>
-                  </a:lnTo>
-                  <a:lnTo>
-                    <a:pt x="6666776" y="1335900"/>
-                  </a:lnTo>
-                </a:path>
-                <a:path w="6686550" h="1355725">
-                  <a:moveTo>
-                    <a:pt x="19685" y="19685"/>
-                  </a:moveTo>
-                  <a:lnTo>
-                    <a:pt x="1292" y="54116"/>
-                  </a:lnTo>
-                  <a:lnTo>
-                    <a:pt x="0" y="67233"/>
-                  </a:lnTo>
-                  <a:lnTo>
-                    <a:pt x="0" y="1283589"/>
-                  </a:lnTo>
-                  <a:lnTo>
-                    <a:pt x="11329" y="1325705"/>
-                  </a:lnTo>
-                  <a:lnTo>
-                    <a:pt x="15256" y="1331008"/>
-                  </a:lnTo>
-                  <a:lnTo>
-                    <a:pt x="19685" y="1335900"/>
-                  </a:lnTo>
-                </a:path>
-                <a:path w="6686550" h="1355725">
-                  <a:moveTo>
-                    <a:pt x="6666776" y="1335900"/>
-                  </a:moveTo>
-                  <a:lnTo>
-                    <a:pt x="6685176" y="1301469"/>
-                  </a:lnTo>
-                  <a:lnTo>
-                    <a:pt x="6686473" y="1288351"/>
-                  </a:lnTo>
-                  <a:lnTo>
-                    <a:pt x="6686473" y="71996"/>
-                  </a:lnTo>
-                  <a:lnTo>
-                    <a:pt x="6675132" y="29879"/>
-                  </a:lnTo>
-                  <a:lnTo>
-                    <a:pt x="6671204" y="24576"/>
-                  </a:lnTo>
-                  <a:lnTo>
-                    <a:pt x="6666776" y="19685"/>
-                  </a:lnTo>
-                </a:path>
-              </a:pathLst>
-            </a:custGeom>
-            <a:ln w="9525">
-              <a:solidFill>
-                <a:srgbClr val="245BA9"/>
-              </a:solidFill>
-            </a:ln>
-          </p:spPr>
-          <p:txBody>
-            <a:bodyPr wrap="square" lIns="0" tIns="0" rIns="0" bIns="0" rtlCol="0"/>
-            <a:lstStyle/>
-            <a:p>
-              <a:endParaRPr/>
-            </a:p>
-          </p:txBody>
-        </p:sp>
-      </p:grpSp>
+          <a:custGeom>
+            <a:avLst/>
+            <a:gdLst/>
+            <a:ahLst/>
+            <a:cxnLst/>
+            <a:rect l="l" t="t" r="r" b="b"/>
+            <a:pathLst>
+              <a:path w="6686550" h="1355725">
+                <a:moveTo>
+                  <a:pt x="6666776" y="19685"/>
+                </a:moveTo>
+                <a:lnTo>
+                  <a:pt x="6632344" y="1292"/>
+                </a:lnTo>
+                <a:lnTo>
+                  <a:pt x="6619227" y="0"/>
+                </a:lnTo>
+                <a:lnTo>
+                  <a:pt x="67233" y="0"/>
+                </a:lnTo>
+                <a:lnTo>
+                  <a:pt x="29879" y="11329"/>
+                </a:lnTo>
+                <a:lnTo>
+                  <a:pt x="24576" y="15256"/>
+                </a:lnTo>
+                <a:lnTo>
+                  <a:pt x="19685" y="19685"/>
+                </a:lnTo>
+              </a:path>
+              <a:path w="6686550" h="1355725">
+                <a:moveTo>
+                  <a:pt x="19685" y="1335900"/>
+                </a:moveTo>
+                <a:lnTo>
+                  <a:pt x="54116" y="1354293"/>
+                </a:lnTo>
+                <a:lnTo>
+                  <a:pt x="67233" y="1355585"/>
+                </a:lnTo>
+                <a:lnTo>
+                  <a:pt x="6614464" y="1355585"/>
+                </a:lnTo>
+                <a:lnTo>
+                  <a:pt x="6656585" y="1344255"/>
+                </a:lnTo>
+                <a:lnTo>
+                  <a:pt x="6661886" y="1340328"/>
+                </a:lnTo>
+                <a:lnTo>
+                  <a:pt x="6666776" y="1335900"/>
+                </a:lnTo>
+              </a:path>
+              <a:path w="6686550" h="1355725">
+                <a:moveTo>
+                  <a:pt x="19685" y="19685"/>
+                </a:moveTo>
+                <a:lnTo>
+                  <a:pt x="1292" y="54116"/>
+                </a:lnTo>
+                <a:lnTo>
+                  <a:pt x="0" y="67233"/>
+                </a:lnTo>
+                <a:lnTo>
+                  <a:pt x="0" y="1283589"/>
+                </a:lnTo>
+                <a:lnTo>
+                  <a:pt x="11329" y="1325705"/>
+                </a:lnTo>
+                <a:lnTo>
+                  <a:pt x="15256" y="1331008"/>
+                </a:lnTo>
+                <a:lnTo>
+                  <a:pt x="19685" y="1335900"/>
+                </a:lnTo>
+              </a:path>
+              <a:path w="6686550" h="1355725">
+                <a:moveTo>
+                  <a:pt x="6666776" y="1335900"/>
+                </a:moveTo>
+                <a:lnTo>
+                  <a:pt x="6685176" y="1301469"/>
+                </a:lnTo>
+                <a:lnTo>
+                  <a:pt x="6686473" y="1288351"/>
+                </a:lnTo>
+                <a:lnTo>
+                  <a:pt x="6686473" y="71996"/>
+                </a:lnTo>
+                <a:lnTo>
+                  <a:pt x="6675132" y="29879"/>
+                </a:lnTo>
+                <a:lnTo>
+                  <a:pt x="6671204" y="24576"/>
+                </a:lnTo>
+                <a:lnTo>
+                  <a:pt x="6666776" y="19685"/>
+                </a:lnTo>
+              </a:path>
+            </a:pathLst>
+          </a:custGeom>
+          <a:ln w="9525">
+            <a:solidFill>
+              <a:srgbClr val="245BA9"/>
+            </a:solidFill>
+          </a:ln>
+        </p:spPr>
+        <p:txBody>
+          <a:bodyPr wrap="square" lIns="0" tIns="0" rIns="0" bIns="0" rtlCol="0"/>
+          <a:lstStyle/>
+          <a:p>
+            <a:endParaRPr/>
+          </a:p>
+        </p:txBody>
+      </p:sp>
       <p:sp>
         <p:nvSpPr>
           <p:cNvPr id="26" name="object 26"/>
@@ -7807,6 +7816,39 @@
           </a:p>
         </p:txBody>
       </p:sp>
+      <p:pic>
+        <p:nvPicPr>
+          <p:cNvPr id="34" name="Picture 5"/>
+          <p:cNvPicPr>
+            <a:picLocks noChangeAspect="1" noChangeArrowheads="1"/>
+          </p:cNvPicPr>
+          <p:nvPr/>
+        </p:nvPicPr>
+        <p:blipFill>
+          <a:blip r:embed="rId7" cstate="print"/>
+          <a:srcRect/>
+          <a:stretch>
+            <a:fillRect/>
+          </a:stretch>
+        </p:blipFill>
+        <p:spPr bwMode="auto">
+          <a:xfrm>
+            <a:off x="8851899" y="5838825"/>
+            <a:ext cx="1004819" cy="990600"/>
+          </a:xfrm>
+          <a:prstGeom prst="rect">
+            <a:avLst/>
+          </a:prstGeom>
+          <a:noFill/>
+          <a:ln w="9525">
+            <a:noFill/>
+            <a:miter lim="800000"/>
+            <a:headEnd/>
+            <a:tailEnd/>
+          </a:ln>
+          <a:effectLst/>
+        </p:spPr>
+      </p:pic>
     </p:spTree>
   </p:cSld>
   <p:clrMapOvr>
@@ -9886,193 +9928,189 @@
           </a:p>
         </p:txBody>
       </p:sp>
-      <p:grpSp>
-        <p:nvGrpSpPr>
-          <p:cNvPr id="31" name="object 31"/>
-          <p:cNvGrpSpPr/>
+      <p:sp>
+        <p:nvSpPr>
+          <p:cNvPr id="32" name="object 32"/>
+          <p:cNvSpPr/>
           <p:nvPr/>
-        </p:nvGrpSpPr>
-        <p:grpSpPr>
+        </p:nvSpPr>
+        <p:spPr>
           <a:xfrm>
-            <a:off x="3692994" y="4646740"/>
-            <a:ext cx="6207125" cy="2479040"/>
-            <a:chOff x="3692994" y="4646740"/>
-            <a:chExt cx="6207125" cy="2479040"/>
+            <a:off x="3702519" y="5998058"/>
+            <a:ext cx="3128010" cy="1118235"/>
           </a:xfrm>
-        </p:grpSpPr>
-        <p:sp>
-          <p:nvSpPr>
-            <p:cNvPr id="32" name="object 32"/>
-            <p:cNvSpPr/>
-            <p:nvPr/>
-          </p:nvSpPr>
-          <p:spPr>
-            <a:xfrm>
-              <a:off x="3702519" y="5998058"/>
-              <a:ext cx="3128010" cy="1118235"/>
-            </a:xfrm>
-            <a:custGeom>
-              <a:avLst/>
-              <a:gdLst/>
-              <a:ahLst/>
-              <a:cxnLst/>
-              <a:rect l="l" t="t" r="r" b="b"/>
-              <a:pathLst>
-                <a:path w="3128009" h="1118234">
-                  <a:moveTo>
-                    <a:pt x="3088563" y="39382"/>
-                  </a:moveTo>
-                  <a:lnTo>
-                    <a:pt x="3056868" y="15879"/>
-                  </a:lnTo>
-                  <a:lnTo>
-                    <a:pt x="3019713" y="2589"/>
-                  </a:lnTo>
-                  <a:lnTo>
-                    <a:pt x="2993478" y="0"/>
-                  </a:lnTo>
-                  <a:lnTo>
-                    <a:pt x="134480" y="0"/>
-                  </a:lnTo>
-                  <a:lnTo>
-                    <a:pt x="95443" y="5791"/>
-                  </a:lnTo>
-                  <a:lnTo>
-                    <a:pt x="59774" y="22666"/>
-                  </a:lnTo>
-                  <a:lnTo>
-                    <a:pt x="49174" y="30524"/>
-                  </a:lnTo>
-                  <a:lnTo>
-                    <a:pt x="39395" y="39382"/>
-                  </a:lnTo>
-                </a:path>
-                <a:path w="3128009" h="1118234">
-                  <a:moveTo>
-                    <a:pt x="39395" y="1078420"/>
-                  </a:moveTo>
-                  <a:lnTo>
-                    <a:pt x="71090" y="1101930"/>
-                  </a:lnTo>
-                  <a:lnTo>
-                    <a:pt x="108245" y="1115221"/>
-                  </a:lnTo>
-                  <a:lnTo>
-                    <a:pt x="134480" y="1117815"/>
-                  </a:lnTo>
-                  <a:lnTo>
-                    <a:pt x="2983953" y="1117815"/>
-                  </a:lnTo>
-                  <a:lnTo>
-                    <a:pt x="3032367" y="1112018"/>
-                  </a:lnTo>
-                  <a:lnTo>
-                    <a:pt x="3068185" y="1095143"/>
-                  </a:lnTo>
-                  <a:lnTo>
-                    <a:pt x="3078784" y="1087284"/>
-                  </a:lnTo>
-                  <a:lnTo>
-                    <a:pt x="3088563" y="1078420"/>
-                  </a:lnTo>
-                </a:path>
-                <a:path w="3128009" h="1118234">
-                  <a:moveTo>
-                    <a:pt x="39395" y="39382"/>
-                  </a:moveTo>
-                  <a:lnTo>
-                    <a:pt x="15887" y="71083"/>
-                  </a:lnTo>
-                  <a:lnTo>
-                    <a:pt x="2593" y="108237"/>
-                  </a:lnTo>
-                  <a:lnTo>
-                    <a:pt x="0" y="134467"/>
-                  </a:lnTo>
-                  <a:lnTo>
-                    <a:pt x="0" y="973810"/>
-                  </a:lnTo>
-                  <a:lnTo>
-                    <a:pt x="5797" y="1022223"/>
-                  </a:lnTo>
-                  <a:lnTo>
-                    <a:pt x="22677" y="1058041"/>
-                  </a:lnTo>
-                  <a:lnTo>
-                    <a:pt x="30536" y="1068641"/>
-                  </a:lnTo>
-                  <a:lnTo>
-                    <a:pt x="39395" y="1078420"/>
-                  </a:lnTo>
-                </a:path>
-                <a:path w="3128009" h="1118234">
-                  <a:moveTo>
-                    <a:pt x="3088563" y="1078420"/>
-                  </a:moveTo>
-                  <a:lnTo>
-                    <a:pt x="3112072" y="1046725"/>
-                  </a:lnTo>
-                  <a:lnTo>
-                    <a:pt x="3125365" y="1009570"/>
-                  </a:lnTo>
-                  <a:lnTo>
-                    <a:pt x="3127959" y="983335"/>
-                  </a:lnTo>
-                  <a:lnTo>
-                    <a:pt x="3127959" y="143992"/>
-                  </a:lnTo>
-                  <a:lnTo>
-                    <a:pt x="3122162" y="95584"/>
-                  </a:lnTo>
-                  <a:lnTo>
-                    <a:pt x="3105281" y="59766"/>
-                  </a:lnTo>
-                  <a:lnTo>
-                    <a:pt x="3097422" y="49163"/>
-                  </a:lnTo>
-                  <a:lnTo>
-                    <a:pt x="3088563" y="39382"/>
-                  </a:lnTo>
-                </a:path>
-              </a:pathLst>
-            </a:custGeom>
-            <a:ln w="19050">
-              <a:solidFill>
-                <a:srgbClr val="245BA9"/>
-              </a:solidFill>
-            </a:ln>
-          </p:spPr>
-          <p:txBody>
-            <a:bodyPr wrap="square" lIns="0" tIns="0" rIns="0" bIns="0" rtlCol="0"/>
-            <a:lstStyle/>
-            <a:p>
-              <a:endParaRPr/>
-            </a:p>
-          </p:txBody>
-        </p:sp>
-        <p:pic>
-          <p:nvPicPr>
-            <p:cNvPr id="33" name="object 33"/>
-            <p:cNvPicPr/>
-            <p:nvPr/>
-          </p:nvPicPr>
-          <p:blipFill>
-            <a:blip r:embed="rId2" cstate="print"/>
-            <a:stretch>
-              <a:fillRect/>
-            </a:stretch>
-          </p:blipFill>
-          <p:spPr>
-            <a:xfrm>
-              <a:off x="8099996" y="4646740"/>
-              <a:ext cx="1799996" cy="1799996"/>
-            </a:xfrm>
-            <a:prstGeom prst="rect">
-              <a:avLst/>
-            </a:prstGeom>
-          </p:spPr>
-        </p:pic>
-      </p:grpSp>
+          <a:custGeom>
+            <a:avLst/>
+            <a:gdLst/>
+            <a:ahLst/>
+            <a:cxnLst/>
+            <a:rect l="l" t="t" r="r" b="b"/>
+            <a:pathLst>
+              <a:path w="3128009" h="1118234">
+                <a:moveTo>
+                  <a:pt x="3088563" y="39382"/>
+                </a:moveTo>
+                <a:lnTo>
+                  <a:pt x="3056868" y="15879"/>
+                </a:lnTo>
+                <a:lnTo>
+                  <a:pt x="3019713" y="2589"/>
+                </a:lnTo>
+                <a:lnTo>
+                  <a:pt x="2993478" y="0"/>
+                </a:lnTo>
+                <a:lnTo>
+                  <a:pt x="134480" y="0"/>
+                </a:lnTo>
+                <a:lnTo>
+                  <a:pt x="95443" y="5791"/>
+                </a:lnTo>
+                <a:lnTo>
+                  <a:pt x="59774" y="22666"/>
+                </a:lnTo>
+                <a:lnTo>
+                  <a:pt x="49174" y="30524"/>
+                </a:lnTo>
+                <a:lnTo>
+                  <a:pt x="39395" y="39382"/>
+                </a:lnTo>
+              </a:path>
+              <a:path w="3128009" h="1118234">
+                <a:moveTo>
+                  <a:pt x="39395" y="1078420"/>
+                </a:moveTo>
+                <a:lnTo>
+                  <a:pt x="71090" y="1101930"/>
+                </a:lnTo>
+                <a:lnTo>
+                  <a:pt x="108245" y="1115221"/>
+                </a:lnTo>
+                <a:lnTo>
+                  <a:pt x="134480" y="1117815"/>
+                </a:lnTo>
+                <a:lnTo>
+                  <a:pt x="2983953" y="1117815"/>
+                </a:lnTo>
+                <a:lnTo>
+                  <a:pt x="3032367" y="1112018"/>
+                </a:lnTo>
+                <a:lnTo>
+                  <a:pt x="3068185" y="1095143"/>
+                </a:lnTo>
+                <a:lnTo>
+                  <a:pt x="3078784" y="1087284"/>
+                </a:lnTo>
+                <a:lnTo>
+                  <a:pt x="3088563" y="1078420"/>
+                </a:lnTo>
+              </a:path>
+              <a:path w="3128009" h="1118234">
+                <a:moveTo>
+                  <a:pt x="39395" y="39382"/>
+                </a:moveTo>
+                <a:lnTo>
+                  <a:pt x="15887" y="71083"/>
+                </a:lnTo>
+                <a:lnTo>
+                  <a:pt x="2593" y="108237"/>
+                </a:lnTo>
+                <a:lnTo>
+                  <a:pt x="0" y="134467"/>
+                </a:lnTo>
+                <a:lnTo>
+                  <a:pt x="0" y="973810"/>
+                </a:lnTo>
+                <a:lnTo>
+                  <a:pt x="5797" y="1022223"/>
+                </a:lnTo>
+                <a:lnTo>
+                  <a:pt x="22677" y="1058041"/>
+                </a:lnTo>
+                <a:lnTo>
+                  <a:pt x="30536" y="1068641"/>
+                </a:lnTo>
+                <a:lnTo>
+                  <a:pt x="39395" y="1078420"/>
+                </a:lnTo>
+              </a:path>
+              <a:path w="3128009" h="1118234">
+                <a:moveTo>
+                  <a:pt x="3088563" y="1078420"/>
+                </a:moveTo>
+                <a:lnTo>
+                  <a:pt x="3112072" y="1046725"/>
+                </a:lnTo>
+                <a:lnTo>
+                  <a:pt x="3125365" y="1009570"/>
+                </a:lnTo>
+                <a:lnTo>
+                  <a:pt x="3127959" y="983335"/>
+                </a:lnTo>
+                <a:lnTo>
+                  <a:pt x="3127959" y="143992"/>
+                </a:lnTo>
+                <a:lnTo>
+                  <a:pt x="3122162" y="95584"/>
+                </a:lnTo>
+                <a:lnTo>
+                  <a:pt x="3105281" y="59766"/>
+                </a:lnTo>
+                <a:lnTo>
+                  <a:pt x="3097422" y="49163"/>
+                </a:lnTo>
+                <a:lnTo>
+                  <a:pt x="3088563" y="39382"/>
+                </a:lnTo>
+              </a:path>
+            </a:pathLst>
+          </a:custGeom>
+          <a:ln w="19050">
+            <a:solidFill>
+              <a:srgbClr val="245BA9"/>
+            </a:solidFill>
+          </a:ln>
+        </p:spPr>
+        <p:txBody>
+          <a:bodyPr wrap="square" lIns="0" tIns="0" rIns="0" bIns="0" rtlCol="0"/>
+          <a:lstStyle/>
+          <a:p>
+            <a:endParaRPr/>
+          </a:p>
+        </p:txBody>
+      </p:sp>
+      <p:pic>
+        <p:nvPicPr>
+          <p:cNvPr id="34" name="Picture 5"/>
+          <p:cNvPicPr>
+            <a:picLocks noChangeAspect="1" noChangeArrowheads="1"/>
+          </p:cNvPicPr>
+          <p:nvPr/>
+        </p:nvPicPr>
+        <p:blipFill>
+          <a:blip r:embed="rId2" cstate="print"/>
+          <a:srcRect/>
+          <a:stretch>
+            <a:fillRect/>
+          </a:stretch>
+        </p:blipFill>
+        <p:spPr bwMode="auto">
+          <a:xfrm>
+            <a:off x="8318500" y="4772025"/>
+            <a:ext cx="1447800" cy="1427313"/>
+          </a:xfrm>
+          <a:prstGeom prst="rect">
+            <a:avLst/>
+          </a:prstGeom>
+          <a:noFill/>
+          <a:ln w="9525">
+            <a:noFill/>
+            <a:miter lim="800000"/>
+            <a:headEnd/>
+            <a:tailEnd/>
+          </a:ln>
+          <a:effectLst/>
+        </p:spPr>
+      </p:pic>
     </p:spTree>
   </p:cSld>
   <p:clrMapOvr>
@@ -10747,193 +10785,156 @@
           </a:p>
         </p:txBody>
       </p:sp>
-      <p:grpSp>
-        <p:nvGrpSpPr>
-          <p:cNvPr id="13" name="object 13"/>
-          <p:cNvGrpSpPr/>
+      <p:sp>
+        <p:nvSpPr>
+          <p:cNvPr id="14" name="object 14"/>
+          <p:cNvSpPr/>
           <p:nvPr/>
-        </p:nvGrpSpPr>
-        <p:grpSpPr>
+        </p:nvSpPr>
+        <p:spPr>
           <a:xfrm>
-            <a:off x="359994" y="6054966"/>
-            <a:ext cx="9900285" cy="989330"/>
-            <a:chOff x="359994" y="6054966"/>
-            <a:chExt cx="9900285" cy="989330"/>
+            <a:off x="364756" y="6688785"/>
+            <a:ext cx="802005" cy="350520"/>
           </a:xfrm>
-        </p:grpSpPr>
-        <p:sp>
-          <p:nvSpPr>
-            <p:cNvPr id="14" name="object 14"/>
-            <p:cNvSpPr/>
-            <p:nvPr/>
-          </p:nvSpPr>
-          <p:spPr>
-            <a:xfrm>
-              <a:off x="364756" y="6688785"/>
-              <a:ext cx="802005" cy="350520"/>
-            </a:xfrm>
-            <a:custGeom>
-              <a:avLst/>
-              <a:gdLst/>
-              <a:ahLst/>
-              <a:cxnLst/>
-              <a:rect l="l" t="t" r="r" b="b"/>
-              <a:pathLst>
-                <a:path w="802005" h="350520">
-                  <a:moveTo>
-                    <a:pt x="750214" y="51320"/>
-                  </a:moveTo>
-                  <a:lnTo>
-                    <a:pt x="708907" y="20691"/>
-                  </a:lnTo>
-                  <a:lnTo>
-                    <a:pt x="660493" y="3376"/>
-                  </a:lnTo>
-                  <a:lnTo>
-                    <a:pt x="626313" y="0"/>
-                  </a:lnTo>
-                  <a:lnTo>
-                    <a:pt x="175221" y="0"/>
-                  </a:lnTo>
-                  <a:lnTo>
-                    <a:pt x="124360" y="7549"/>
-                  </a:lnTo>
-                  <a:lnTo>
-                    <a:pt x="77881" y="29537"/>
-                  </a:lnTo>
-                  <a:lnTo>
-                    <a:pt x="64065" y="39777"/>
-                  </a:lnTo>
-                  <a:lnTo>
-                    <a:pt x="51320" y="51320"/>
-                  </a:lnTo>
-                </a:path>
-                <a:path w="802005" h="350520">
-                  <a:moveTo>
-                    <a:pt x="51320" y="299161"/>
-                  </a:moveTo>
-                  <a:lnTo>
-                    <a:pt x="92627" y="329779"/>
-                  </a:lnTo>
-                  <a:lnTo>
-                    <a:pt x="141041" y="347092"/>
-                  </a:lnTo>
-                  <a:lnTo>
-                    <a:pt x="175221" y="350469"/>
-                  </a:lnTo>
-                  <a:lnTo>
-                    <a:pt x="621550" y="350469"/>
-                  </a:lnTo>
-                  <a:lnTo>
-                    <a:pt x="659898" y="347092"/>
-                  </a:lnTo>
-                  <a:lnTo>
-                    <a:pt x="708907" y="329779"/>
-                  </a:lnTo>
-                  <a:lnTo>
-                    <a:pt x="737469" y="310702"/>
-                  </a:lnTo>
-                  <a:lnTo>
-                    <a:pt x="750214" y="299161"/>
-                  </a:lnTo>
-                </a:path>
-                <a:path w="802005" h="350520">
-                  <a:moveTo>
-                    <a:pt x="51320" y="51320"/>
-                  </a:moveTo>
-                  <a:lnTo>
-                    <a:pt x="20702" y="92627"/>
-                  </a:lnTo>
-                  <a:lnTo>
-                    <a:pt x="3382" y="141041"/>
-                  </a:lnTo>
-                  <a:lnTo>
-                    <a:pt x="0" y="175221"/>
-                  </a:lnTo>
-                  <a:lnTo>
-                    <a:pt x="0" y="170497"/>
-                  </a:lnTo>
-                  <a:lnTo>
-                    <a:pt x="3382" y="208843"/>
-                  </a:lnTo>
-                  <a:lnTo>
-                    <a:pt x="20702" y="257847"/>
-                  </a:lnTo>
-                  <a:lnTo>
-                    <a:pt x="39779" y="286410"/>
-                  </a:lnTo>
-                  <a:lnTo>
-                    <a:pt x="51320" y="299161"/>
-                  </a:lnTo>
-                </a:path>
-                <a:path w="802005" h="350520">
-                  <a:moveTo>
-                    <a:pt x="750214" y="299161"/>
-                  </a:moveTo>
-                  <a:lnTo>
-                    <a:pt x="780832" y="257847"/>
-                  </a:lnTo>
-                  <a:lnTo>
-                    <a:pt x="798156" y="209438"/>
-                  </a:lnTo>
-                  <a:lnTo>
-                    <a:pt x="801535" y="175260"/>
-                  </a:lnTo>
-                  <a:lnTo>
-                    <a:pt x="801535" y="179984"/>
-                  </a:lnTo>
-                  <a:lnTo>
-                    <a:pt x="798156" y="141636"/>
-                  </a:lnTo>
-                  <a:lnTo>
-                    <a:pt x="780832" y="92627"/>
-                  </a:lnTo>
-                  <a:lnTo>
-                    <a:pt x="761755" y="64065"/>
-                  </a:lnTo>
-                  <a:lnTo>
-                    <a:pt x="750214" y="51320"/>
-                  </a:lnTo>
-                </a:path>
-              </a:pathLst>
-            </a:custGeom>
-            <a:ln w="9525">
-              <a:solidFill>
-                <a:srgbClr val="9CC9ED"/>
-              </a:solidFill>
-            </a:ln>
-          </p:spPr>
-          <p:txBody>
-            <a:bodyPr wrap="square" lIns="0" tIns="0" rIns="0" bIns="0" rtlCol="0"/>
-            <a:lstStyle/>
-            <a:p>
-              <a:endParaRPr/>
-            </a:p>
-          </p:txBody>
-        </p:sp>
-        <p:pic>
-          <p:nvPicPr>
-            <p:cNvPr id="15" name="object 15"/>
-            <p:cNvPicPr/>
-            <p:nvPr/>
-          </p:nvPicPr>
-          <p:blipFill>
-            <a:blip r:embed="rId7" cstate="print"/>
-            <a:stretch>
-              <a:fillRect/>
-            </a:stretch>
-          </p:blipFill>
-          <p:spPr>
-            <a:xfrm>
-              <a:off x="9323997" y="6054966"/>
-              <a:ext cx="936002" cy="936002"/>
-            </a:xfrm>
-            <a:prstGeom prst="rect">
-              <a:avLst/>
-            </a:prstGeom>
-          </p:spPr>
-        </p:pic>
-      </p:grpSp>
+          <a:custGeom>
+            <a:avLst/>
+            <a:gdLst/>
+            <a:ahLst/>
+            <a:cxnLst/>
+            <a:rect l="l" t="t" r="r" b="b"/>
+            <a:pathLst>
+              <a:path w="802005" h="350520">
+                <a:moveTo>
+                  <a:pt x="750214" y="51320"/>
+                </a:moveTo>
+                <a:lnTo>
+                  <a:pt x="708907" y="20691"/>
+                </a:lnTo>
+                <a:lnTo>
+                  <a:pt x="660493" y="3376"/>
+                </a:lnTo>
+                <a:lnTo>
+                  <a:pt x="626313" y="0"/>
+                </a:lnTo>
+                <a:lnTo>
+                  <a:pt x="175221" y="0"/>
+                </a:lnTo>
+                <a:lnTo>
+                  <a:pt x="124360" y="7549"/>
+                </a:lnTo>
+                <a:lnTo>
+                  <a:pt x="77881" y="29537"/>
+                </a:lnTo>
+                <a:lnTo>
+                  <a:pt x="64065" y="39777"/>
+                </a:lnTo>
+                <a:lnTo>
+                  <a:pt x="51320" y="51320"/>
+                </a:lnTo>
+              </a:path>
+              <a:path w="802005" h="350520">
+                <a:moveTo>
+                  <a:pt x="51320" y="299161"/>
+                </a:moveTo>
+                <a:lnTo>
+                  <a:pt x="92627" y="329779"/>
+                </a:lnTo>
+                <a:lnTo>
+                  <a:pt x="141041" y="347092"/>
+                </a:lnTo>
+                <a:lnTo>
+                  <a:pt x="175221" y="350469"/>
+                </a:lnTo>
+                <a:lnTo>
+                  <a:pt x="621550" y="350469"/>
+                </a:lnTo>
+                <a:lnTo>
+                  <a:pt x="659898" y="347092"/>
+                </a:lnTo>
+                <a:lnTo>
+                  <a:pt x="708907" y="329779"/>
+                </a:lnTo>
+                <a:lnTo>
+                  <a:pt x="737469" y="310702"/>
+                </a:lnTo>
+                <a:lnTo>
+                  <a:pt x="750214" y="299161"/>
+                </a:lnTo>
+              </a:path>
+              <a:path w="802005" h="350520">
+                <a:moveTo>
+                  <a:pt x="51320" y="51320"/>
+                </a:moveTo>
+                <a:lnTo>
+                  <a:pt x="20702" y="92627"/>
+                </a:lnTo>
+                <a:lnTo>
+                  <a:pt x="3382" y="141041"/>
+                </a:lnTo>
+                <a:lnTo>
+                  <a:pt x="0" y="175221"/>
+                </a:lnTo>
+                <a:lnTo>
+                  <a:pt x="0" y="170497"/>
+                </a:lnTo>
+                <a:lnTo>
+                  <a:pt x="3382" y="208843"/>
+                </a:lnTo>
+                <a:lnTo>
+                  <a:pt x="20702" y="257847"/>
+                </a:lnTo>
+                <a:lnTo>
+                  <a:pt x="39779" y="286410"/>
+                </a:lnTo>
+                <a:lnTo>
+                  <a:pt x="51320" y="299161"/>
+                </a:lnTo>
+              </a:path>
+              <a:path w="802005" h="350520">
+                <a:moveTo>
+                  <a:pt x="750214" y="299161"/>
+                </a:moveTo>
+                <a:lnTo>
+                  <a:pt x="780832" y="257847"/>
+                </a:lnTo>
+                <a:lnTo>
+                  <a:pt x="798156" y="209438"/>
+                </a:lnTo>
+                <a:lnTo>
+                  <a:pt x="801535" y="175260"/>
+                </a:lnTo>
+                <a:lnTo>
+                  <a:pt x="801535" y="179984"/>
+                </a:lnTo>
+                <a:lnTo>
+                  <a:pt x="798156" y="141636"/>
+                </a:lnTo>
+                <a:lnTo>
+                  <a:pt x="780832" y="92627"/>
+                </a:lnTo>
+                <a:lnTo>
+                  <a:pt x="761755" y="64065"/>
+                </a:lnTo>
+                <a:lnTo>
+                  <a:pt x="750214" y="51320"/>
+                </a:lnTo>
+              </a:path>
+            </a:pathLst>
+          </a:custGeom>
+          <a:ln w="9525">
+            <a:solidFill>
+              <a:srgbClr val="9CC9ED"/>
+            </a:solidFill>
+          </a:ln>
+        </p:spPr>
+        <p:txBody>
+          <a:bodyPr wrap="square" lIns="0" tIns="0" rIns="0" bIns="0" rtlCol="0"/>
+          <a:lstStyle/>
+          <a:p>
+            <a:endParaRPr/>
+          </a:p>
+        </p:txBody>
+      </p:sp>
       <p:sp>
         <p:nvSpPr>
           <p:cNvPr id="16" name="object 16"/>
@@ -12666,6 +12667,39 @@
           </a:p>
         </p:txBody>
       </p:sp>
+      <p:pic>
+        <p:nvPicPr>
+          <p:cNvPr id="27" name="Picture 5"/>
+          <p:cNvPicPr>
+            <a:picLocks noChangeAspect="1" noChangeArrowheads="1"/>
+          </p:cNvPicPr>
+          <p:nvPr/>
+        </p:nvPicPr>
+        <p:blipFill>
+          <a:blip r:embed="rId7" cstate="print"/>
+          <a:srcRect/>
+          <a:stretch>
+            <a:fillRect/>
+          </a:stretch>
+        </p:blipFill>
+        <p:spPr bwMode="auto">
+          <a:xfrm>
+            <a:off x="9279431" y="6048375"/>
+            <a:ext cx="991694" cy="977660"/>
+          </a:xfrm>
+          <a:prstGeom prst="rect">
+            <a:avLst/>
+          </a:prstGeom>
+          <a:noFill/>
+          <a:ln w="9525">
+            <a:noFill/>
+            <a:miter lim="800000"/>
+            <a:headEnd/>
+            <a:tailEnd/>
+          </a:ln>
+          <a:effectLst/>
+        </p:spPr>
+      </p:pic>
     </p:spTree>
   </p:cSld>
   <p:clrMapOvr>
@@ -17272,7 +17306,7 @@
         <p:spPr>
           <a:xfrm>
             <a:off x="5567298" y="1670151"/>
-            <a:ext cx="2032635" cy="603885"/>
+            <a:ext cx="3284602" cy="602729"/>
           </a:xfrm>
           <a:prstGeom prst="rect">
             <a:avLst/>
@@ -17293,25 +17327,11 @@
               </a:spcBef>
             </a:pPr>
             <a:r>
-              <a:rPr lang="ru-RU" sz="1800" dirty="0" err="1" smtClean="0">
-                <a:latin typeface="Century Gothic"/>
-                <a:cs typeface="Century Gothic"/>
-              </a:rPr>
-              <a:t>Мункуева</a:t>
-            </a:r>
-            <a:r>
-              <a:rPr lang="ru-RU" sz="1800" spc="85" dirty="0" smtClean="0">
-                <a:latin typeface="Century Gothic"/>
-                <a:cs typeface="Century Gothic"/>
-              </a:rPr>
-              <a:t> </a:t>
-            </a:r>
-            <a:r>
-              <a:rPr lang="ru-RU" sz="1800" spc="-25" dirty="0" smtClean="0">
-                <a:latin typeface="Century Gothic"/>
-                <a:cs typeface="Century Gothic"/>
-              </a:rPr>
-              <a:t>Зоя</a:t>
+              <a:rPr lang="ru-RU" sz="1800" dirty="0" smtClean="0">
+                <a:latin typeface="Century Gothic"/>
+                <a:cs typeface="Century Gothic"/>
+              </a:rPr>
+              <a:t>Вострикова Татьяна</a:t>
             </a:r>
             <a:endParaRPr lang="ru-RU" sz="1800" dirty="0" smtClean="0">
               <a:latin typeface="Century Gothic"/>
@@ -17722,7 +17742,7 @@
         <p:spPr>
           <a:xfrm>
             <a:off x="5579998" y="3433965"/>
-            <a:ext cx="1872614" cy="275717"/>
+            <a:ext cx="4033902" cy="275717"/>
           </a:xfrm>
           <a:prstGeom prst="rect">
             <a:avLst/>
@@ -17743,11 +17763,24 @@
               </a:spcBef>
             </a:pPr>
             <a:r>
-              <a:rPr lang="ru-RU" sz="1200" spc="-10" dirty="0" smtClean="0">
-                <a:latin typeface="Century Gothic"/>
-                <a:cs typeface="Century Gothic"/>
-              </a:rPr>
-              <a:t>+79006574280</a:t>
+              <a:rPr lang="en-US" sz="1200" dirty="0" smtClean="0"/>
+              <a:t> </a:t>
+            </a:r>
+            <a:r>
+              <a:rPr lang="en-US" sz="1200" dirty="0"/>
+              <a:t>+</a:t>
+            </a:r>
+            <a:r>
+              <a:rPr lang="en-US" sz="1200" dirty="0" smtClean="0"/>
+              <a:t>79219512113</a:t>
+            </a:r>
+            <a:r>
+              <a:rPr lang="ru-RU" sz="1200" dirty="0" smtClean="0"/>
+              <a:t>         </a:t>
+            </a:r>
+            <a:r>
+              <a:rPr lang="en-US" sz="1200" dirty="0" smtClean="0"/>
+              <a:t>manager49@imperia-forums.ru</a:t>
             </a:r>
             <a:endParaRPr lang="ru-RU" sz="1200" dirty="0">
               <a:latin typeface="Century Gothic"/>
@@ -17756,788 +17789,6 @@
           </a:p>
         </p:txBody>
       </p:sp>
-      <p:grpSp>
-        <p:nvGrpSpPr>
-          <p:cNvPr id="18" name="object 18"/>
-          <p:cNvGrpSpPr/>
-          <p:nvPr/>
-        </p:nvGrpSpPr>
-        <p:grpSpPr>
-          <a:xfrm>
-            <a:off x="7472247" y="3433724"/>
-            <a:ext cx="1887855" cy="900430"/>
-            <a:chOff x="7472247" y="3433724"/>
-            <a:chExt cx="1887855" cy="900430"/>
-          </a:xfrm>
-        </p:grpSpPr>
-        <p:sp>
-          <p:nvSpPr>
-            <p:cNvPr id="19" name="object 19">
-              <a:hlinkClick r:id="rId7"/>
-            </p:cNvPr>
-            <p:cNvSpPr/>
-            <p:nvPr/>
-          </p:nvSpPr>
-          <p:spPr>
-            <a:xfrm>
-              <a:off x="7472247" y="3454208"/>
-              <a:ext cx="283845" cy="283845"/>
-            </a:xfrm>
-            <a:custGeom>
-              <a:avLst/>
-              <a:gdLst/>
-              <a:ahLst/>
-              <a:cxnLst/>
-              <a:rect l="l" t="t" r="r" b="b"/>
-              <a:pathLst>
-                <a:path w="283845" h="283845">
-                  <a:moveTo>
-                    <a:pt x="141734" y="0"/>
-                  </a:moveTo>
-                  <a:lnTo>
-                    <a:pt x="96935" y="7225"/>
-                  </a:lnTo>
-                  <a:lnTo>
-                    <a:pt x="58028" y="27346"/>
-                  </a:lnTo>
-                  <a:lnTo>
-                    <a:pt x="27346" y="58028"/>
-                  </a:lnTo>
-                  <a:lnTo>
-                    <a:pt x="7225" y="96935"/>
-                  </a:lnTo>
-                  <a:lnTo>
-                    <a:pt x="0" y="141734"/>
-                  </a:lnTo>
-                  <a:lnTo>
-                    <a:pt x="7225" y="186531"/>
-                  </a:lnTo>
-                  <a:lnTo>
-                    <a:pt x="27346" y="225436"/>
-                  </a:lnTo>
-                  <a:lnTo>
-                    <a:pt x="58028" y="256115"/>
-                  </a:lnTo>
-                  <a:lnTo>
-                    <a:pt x="96935" y="276234"/>
-                  </a:lnTo>
-                  <a:lnTo>
-                    <a:pt x="141734" y="283459"/>
-                  </a:lnTo>
-                  <a:lnTo>
-                    <a:pt x="186531" y="276234"/>
-                  </a:lnTo>
-                  <a:lnTo>
-                    <a:pt x="225436" y="256115"/>
-                  </a:lnTo>
-                  <a:lnTo>
-                    <a:pt x="256115" y="225436"/>
-                  </a:lnTo>
-                  <a:lnTo>
-                    <a:pt x="276234" y="186531"/>
-                  </a:lnTo>
-                  <a:lnTo>
-                    <a:pt x="283459" y="141734"/>
-                  </a:lnTo>
-                  <a:lnTo>
-                    <a:pt x="276234" y="96935"/>
-                  </a:lnTo>
-                  <a:lnTo>
-                    <a:pt x="256115" y="58028"/>
-                  </a:lnTo>
-                  <a:lnTo>
-                    <a:pt x="225436" y="27346"/>
-                  </a:lnTo>
-                  <a:lnTo>
-                    <a:pt x="186531" y="7225"/>
-                  </a:lnTo>
-                  <a:lnTo>
-                    <a:pt x="141734" y="0"/>
-                  </a:lnTo>
-                  <a:close/>
-                </a:path>
-              </a:pathLst>
-            </a:custGeom>
-            <a:solidFill>
-              <a:srgbClr val="FFFFFF"/>
-            </a:solidFill>
-          </p:spPr>
-          <p:txBody>
-            <a:bodyPr wrap="square" lIns="0" tIns="0" rIns="0" bIns="0" rtlCol="0"/>
-            <a:lstStyle/>
-            <a:p>
-              <a:endParaRPr/>
-            </a:p>
-          </p:txBody>
-        </p:sp>
-        <p:pic>
-          <p:nvPicPr>
-            <p:cNvPr id="20" name="object 20">
-              <a:hlinkClick r:id="rId7"/>
-            </p:cNvPr>
-            <p:cNvPicPr/>
-            <p:nvPr/>
-          </p:nvPicPr>
-          <p:blipFill>
-            <a:blip r:embed="rId8" cstate="print"/>
-            <a:stretch>
-              <a:fillRect/>
-            </a:stretch>
-          </p:blipFill>
-          <p:spPr>
-            <a:xfrm>
-              <a:off x="7492498" y="3474458"/>
-              <a:ext cx="242965" cy="242963"/>
-            </a:xfrm>
-            <a:prstGeom prst="rect">
-              <a:avLst/>
-            </a:prstGeom>
-          </p:spPr>
-        </p:pic>
-        <p:sp>
-          <p:nvSpPr>
-            <p:cNvPr id="21" name="object 21">
-              <a:hlinkClick r:id="rId9"/>
-            </p:cNvPr>
-            <p:cNvSpPr/>
-            <p:nvPr/>
-          </p:nvSpPr>
-          <p:spPr>
-            <a:xfrm>
-              <a:off x="7784999" y="3442972"/>
-              <a:ext cx="339090" cy="339090"/>
-            </a:xfrm>
-            <a:custGeom>
-              <a:avLst/>
-              <a:gdLst/>
-              <a:ahLst/>
-              <a:cxnLst/>
-              <a:rect l="l" t="t" r="r" b="b"/>
-              <a:pathLst>
-                <a:path w="339090" h="339089">
-                  <a:moveTo>
-                    <a:pt x="169269" y="0"/>
-                  </a:moveTo>
-                  <a:lnTo>
-                    <a:pt x="124269" y="6046"/>
-                  </a:lnTo>
-                  <a:lnTo>
-                    <a:pt x="83834" y="23109"/>
-                  </a:lnTo>
-                  <a:lnTo>
-                    <a:pt x="49576" y="49576"/>
-                  </a:lnTo>
-                  <a:lnTo>
-                    <a:pt x="23109" y="83834"/>
-                  </a:lnTo>
-                  <a:lnTo>
-                    <a:pt x="6046" y="124269"/>
-                  </a:lnTo>
-                  <a:lnTo>
-                    <a:pt x="0" y="169269"/>
-                  </a:lnTo>
-                  <a:lnTo>
-                    <a:pt x="6046" y="214269"/>
-                  </a:lnTo>
-                  <a:lnTo>
-                    <a:pt x="23109" y="254705"/>
-                  </a:lnTo>
-                  <a:lnTo>
-                    <a:pt x="49576" y="288966"/>
-                  </a:lnTo>
-                  <a:lnTo>
-                    <a:pt x="83834" y="315435"/>
-                  </a:lnTo>
-                  <a:lnTo>
-                    <a:pt x="124269" y="332500"/>
-                  </a:lnTo>
-                  <a:lnTo>
-                    <a:pt x="169269" y="338547"/>
-                  </a:lnTo>
-                  <a:lnTo>
-                    <a:pt x="214269" y="332500"/>
-                  </a:lnTo>
-                  <a:lnTo>
-                    <a:pt x="254705" y="315435"/>
-                  </a:lnTo>
-                  <a:lnTo>
-                    <a:pt x="288966" y="288966"/>
-                  </a:lnTo>
-                  <a:lnTo>
-                    <a:pt x="315435" y="254705"/>
-                  </a:lnTo>
-                  <a:lnTo>
-                    <a:pt x="332500" y="214269"/>
-                  </a:lnTo>
-                  <a:lnTo>
-                    <a:pt x="338547" y="169269"/>
-                  </a:lnTo>
-                  <a:lnTo>
-                    <a:pt x="332500" y="124269"/>
-                  </a:lnTo>
-                  <a:lnTo>
-                    <a:pt x="315435" y="83834"/>
-                  </a:lnTo>
-                  <a:lnTo>
-                    <a:pt x="288966" y="49576"/>
-                  </a:lnTo>
-                  <a:lnTo>
-                    <a:pt x="254705" y="23109"/>
-                  </a:lnTo>
-                  <a:lnTo>
-                    <a:pt x="214269" y="6046"/>
-                  </a:lnTo>
-                  <a:lnTo>
-                    <a:pt x="169269" y="0"/>
-                  </a:lnTo>
-                  <a:close/>
-                </a:path>
-              </a:pathLst>
-            </a:custGeom>
-            <a:solidFill>
-              <a:srgbClr val="FFFFFF"/>
-            </a:solidFill>
-          </p:spPr>
-          <p:txBody>
-            <a:bodyPr wrap="square" lIns="0" tIns="0" rIns="0" bIns="0" rtlCol="0"/>
-            <a:lstStyle/>
-            <a:p>
-              <a:endParaRPr/>
-            </a:p>
-          </p:txBody>
-        </p:sp>
-        <p:sp>
-          <p:nvSpPr>
-            <p:cNvPr id="22" name="object 22">
-              <a:hlinkClick r:id="rId9"/>
-            </p:cNvPr>
-            <p:cNvSpPr/>
-            <p:nvPr/>
-          </p:nvSpPr>
-          <p:spPr>
-            <a:xfrm>
-              <a:off x="7811604" y="3470356"/>
-              <a:ext cx="288290" cy="288290"/>
-            </a:xfrm>
-            <a:custGeom>
-              <a:avLst/>
-              <a:gdLst/>
-              <a:ahLst/>
-              <a:cxnLst/>
-              <a:rect l="l" t="t" r="r" b="b"/>
-              <a:pathLst>
-                <a:path w="288290" h="288289">
-                  <a:moveTo>
-                    <a:pt x="223909" y="264338"/>
-                  </a:moveTo>
-                  <a:lnTo>
-                    <a:pt x="65231" y="264338"/>
-                  </a:lnTo>
-                  <a:lnTo>
-                    <a:pt x="70636" y="267939"/>
-                  </a:lnTo>
-                  <a:lnTo>
-                    <a:pt x="88502" y="276353"/>
-                  </a:lnTo>
-                  <a:lnTo>
-                    <a:pt x="106876" y="282574"/>
-                  </a:lnTo>
-                  <a:lnTo>
-                    <a:pt x="125588" y="286432"/>
-                  </a:lnTo>
-                  <a:lnTo>
-                    <a:pt x="144469" y="287756"/>
-                  </a:lnTo>
-                  <a:lnTo>
-                    <a:pt x="164251" y="286432"/>
-                  </a:lnTo>
-                  <a:lnTo>
-                    <a:pt x="164533" y="286432"/>
-                  </a:lnTo>
-                  <a:lnTo>
-                    <a:pt x="184536" y="282350"/>
-                  </a:lnTo>
-                  <a:lnTo>
-                    <a:pt x="203727" y="275596"/>
-                  </a:lnTo>
-                  <a:lnTo>
-                    <a:pt x="221903" y="266143"/>
-                  </a:lnTo>
-                  <a:lnTo>
-                    <a:pt x="223909" y="264338"/>
-                  </a:lnTo>
-                  <a:close/>
-                </a:path>
-                <a:path w="288290" h="288289">
-                  <a:moveTo>
-                    <a:pt x="154511" y="0"/>
-                  </a:moveTo>
-                  <a:lnTo>
-                    <a:pt x="109952" y="3616"/>
-                  </a:lnTo>
-                  <a:lnTo>
-                    <a:pt x="67036" y="21236"/>
-                  </a:lnTo>
-                  <a:lnTo>
-                    <a:pt x="32617" y="51346"/>
-                  </a:lnTo>
-                  <a:lnTo>
-                    <a:pt x="9955" y="89667"/>
-                  </a:lnTo>
-                  <a:lnTo>
-                    <a:pt x="0" y="132741"/>
-                  </a:lnTo>
-                  <a:lnTo>
-                    <a:pt x="3703" y="177111"/>
-                  </a:lnTo>
-                  <a:lnTo>
-                    <a:pt x="22016" y="219318"/>
-                  </a:lnTo>
-                  <a:lnTo>
-                    <a:pt x="25616" y="224724"/>
-                  </a:lnTo>
-                  <a:lnTo>
-                    <a:pt x="11214" y="278750"/>
-                  </a:lnTo>
-                  <a:lnTo>
-                    <a:pt x="65231" y="264338"/>
-                  </a:lnTo>
-                  <a:lnTo>
-                    <a:pt x="223909" y="264338"/>
-                  </a:lnTo>
-                  <a:lnTo>
-                    <a:pt x="256148" y="235329"/>
-                  </a:lnTo>
-                  <a:lnTo>
-                    <a:pt x="262099" y="225061"/>
-                  </a:lnTo>
-                  <a:lnTo>
-                    <a:pt x="194158" y="225061"/>
-                  </a:lnTo>
-                  <a:lnTo>
-                    <a:pt x="184985" y="224724"/>
-                  </a:lnTo>
-                  <a:lnTo>
-                    <a:pt x="148070" y="213922"/>
-                  </a:lnTo>
-                  <a:lnTo>
-                    <a:pt x="106429" y="186232"/>
-                  </a:lnTo>
-                  <a:lnTo>
-                    <a:pt x="74237" y="149095"/>
-                  </a:lnTo>
-                  <a:lnTo>
-                    <a:pt x="56234" y="104075"/>
-                  </a:lnTo>
-                  <a:lnTo>
-                    <a:pt x="57218" y="93633"/>
-                  </a:lnTo>
-                  <a:lnTo>
-                    <a:pt x="77837" y="62655"/>
-                  </a:lnTo>
-                  <a:lnTo>
-                    <a:pt x="263683" y="62655"/>
-                  </a:lnTo>
-                  <a:lnTo>
-                    <a:pt x="236109" y="32011"/>
-                  </a:lnTo>
-                  <a:lnTo>
-                    <a:pt x="197601" y="9695"/>
-                  </a:lnTo>
-                  <a:lnTo>
-                    <a:pt x="154511" y="0"/>
-                  </a:lnTo>
-                  <a:close/>
-                </a:path>
-                <a:path w="288290" h="288289">
-                  <a:moveTo>
-                    <a:pt x="285556" y="165302"/>
-                  </a:moveTo>
-                  <a:lnTo>
-                    <a:pt x="189489" y="165302"/>
-                  </a:lnTo>
-                  <a:lnTo>
-                    <a:pt x="229104" y="185109"/>
-                  </a:lnTo>
-                  <a:lnTo>
-                    <a:pt x="230909" y="186905"/>
-                  </a:lnTo>
-                  <a:lnTo>
-                    <a:pt x="232704" y="192310"/>
-                  </a:lnTo>
-                  <a:lnTo>
-                    <a:pt x="232704" y="199511"/>
-                  </a:lnTo>
-                  <a:lnTo>
-                    <a:pt x="200291" y="224724"/>
-                  </a:lnTo>
-                  <a:lnTo>
-                    <a:pt x="194158" y="225061"/>
-                  </a:lnTo>
-                  <a:lnTo>
-                    <a:pt x="262099" y="225061"/>
-                  </a:lnTo>
-                  <a:lnTo>
-                    <a:pt x="278464" y="196821"/>
-                  </a:lnTo>
-                  <a:lnTo>
-                    <a:pt x="285556" y="165302"/>
-                  </a:lnTo>
-                  <a:close/>
-                </a:path>
-                <a:path w="288290" h="288289">
-                  <a:moveTo>
-                    <a:pt x="263683" y="62655"/>
-                  </a:moveTo>
-                  <a:lnTo>
-                    <a:pt x="97644" y="62655"/>
-                  </a:lnTo>
-                  <a:lnTo>
-                    <a:pt x="99449" y="69856"/>
-                  </a:lnTo>
-                  <a:lnTo>
-                    <a:pt x="107103" y="88763"/>
-                  </a:lnTo>
-                  <a:lnTo>
-                    <a:pt x="110592" y="97710"/>
-                  </a:lnTo>
-                  <a:lnTo>
-                    <a:pt x="112056" y="102270"/>
-                  </a:lnTo>
-                  <a:lnTo>
-                    <a:pt x="113851" y="104075"/>
-                  </a:lnTo>
-                  <a:lnTo>
-                    <a:pt x="113851" y="107675"/>
-                  </a:lnTo>
-                  <a:lnTo>
-                    <a:pt x="112056" y="109471"/>
-                  </a:lnTo>
-                  <a:lnTo>
-                    <a:pt x="113851" y="113071"/>
-                  </a:lnTo>
-                  <a:lnTo>
-                    <a:pt x="112056" y="116681"/>
-                  </a:lnTo>
-                  <a:lnTo>
-                    <a:pt x="108455" y="120282"/>
-                  </a:lnTo>
-                  <a:lnTo>
-                    <a:pt x="106650" y="123882"/>
-                  </a:lnTo>
-                  <a:lnTo>
-                    <a:pt x="104855" y="125678"/>
-                  </a:lnTo>
-                  <a:lnTo>
-                    <a:pt x="101245" y="127483"/>
-                  </a:lnTo>
-                  <a:lnTo>
-                    <a:pt x="99449" y="131083"/>
-                  </a:lnTo>
-                  <a:lnTo>
-                    <a:pt x="101245" y="134684"/>
-                  </a:lnTo>
-                  <a:lnTo>
-                    <a:pt x="126457" y="165302"/>
-                  </a:lnTo>
-                  <a:lnTo>
-                    <a:pt x="160676" y="186905"/>
-                  </a:lnTo>
-                  <a:lnTo>
-                    <a:pt x="164277" y="188710"/>
-                  </a:lnTo>
-                  <a:lnTo>
-                    <a:pt x="167877" y="188710"/>
-                  </a:lnTo>
-                  <a:lnTo>
-                    <a:pt x="171477" y="181509"/>
-                  </a:lnTo>
-                  <a:lnTo>
-                    <a:pt x="187684" y="165302"/>
-                  </a:lnTo>
-                  <a:lnTo>
-                    <a:pt x="285556" y="165302"/>
-                  </a:lnTo>
-                  <a:lnTo>
-                    <a:pt x="288159" y="153731"/>
-                  </a:lnTo>
-                  <a:lnTo>
-                    <a:pt x="284567" y="109471"/>
-                  </a:lnTo>
-                  <a:lnTo>
-                    <a:pt x="284543" y="109172"/>
-                  </a:lnTo>
-                  <a:lnTo>
-                    <a:pt x="266923" y="66256"/>
-                  </a:lnTo>
-                  <a:lnTo>
-                    <a:pt x="263683" y="62655"/>
-                  </a:lnTo>
-                  <a:close/>
-                </a:path>
-              </a:pathLst>
-            </a:custGeom>
-            <a:solidFill>
-              <a:srgbClr val="29AE3D"/>
-            </a:solidFill>
-          </p:spPr>
-          <p:txBody>
-            <a:bodyPr wrap="square" lIns="0" tIns="0" rIns="0" bIns="0" rtlCol="0"/>
-            <a:lstStyle/>
-            <a:p>
-              <a:endParaRPr/>
-            </a:p>
-          </p:txBody>
-        </p:sp>
-        <p:sp>
-          <p:nvSpPr>
-            <p:cNvPr id="23" name="object 23">
-              <a:hlinkClick r:id="rId10"/>
-            </p:cNvPr>
-            <p:cNvSpPr/>
-            <p:nvPr/>
-          </p:nvSpPr>
-          <p:spPr>
-            <a:xfrm>
-              <a:off x="8142160" y="3441662"/>
-              <a:ext cx="289560" cy="289560"/>
-            </a:xfrm>
-            <a:custGeom>
-              <a:avLst/>
-              <a:gdLst/>
-              <a:ahLst/>
-              <a:cxnLst/>
-              <a:rect l="l" t="t" r="r" b="b"/>
-              <a:pathLst>
-                <a:path w="289559" h="289560">
-                  <a:moveTo>
-                    <a:pt x="144754" y="0"/>
-                  </a:moveTo>
-                  <a:lnTo>
-                    <a:pt x="99000" y="7379"/>
-                  </a:lnTo>
-                  <a:lnTo>
-                    <a:pt x="59264" y="27929"/>
-                  </a:lnTo>
-                  <a:lnTo>
-                    <a:pt x="27929" y="59264"/>
-                  </a:lnTo>
-                  <a:lnTo>
-                    <a:pt x="7379" y="99000"/>
-                  </a:lnTo>
-                  <a:lnTo>
-                    <a:pt x="0" y="144754"/>
-                  </a:lnTo>
-                  <a:lnTo>
-                    <a:pt x="7379" y="190502"/>
-                  </a:lnTo>
-                  <a:lnTo>
-                    <a:pt x="27929" y="230235"/>
-                  </a:lnTo>
-                  <a:lnTo>
-                    <a:pt x="59264" y="261568"/>
-                  </a:lnTo>
-                  <a:lnTo>
-                    <a:pt x="99000" y="282116"/>
-                  </a:lnTo>
-                  <a:lnTo>
-                    <a:pt x="144754" y="289496"/>
-                  </a:lnTo>
-                  <a:lnTo>
-                    <a:pt x="190502" y="282116"/>
-                  </a:lnTo>
-                  <a:lnTo>
-                    <a:pt x="230235" y="261568"/>
-                  </a:lnTo>
-                  <a:lnTo>
-                    <a:pt x="261568" y="230235"/>
-                  </a:lnTo>
-                  <a:lnTo>
-                    <a:pt x="282116" y="190502"/>
-                  </a:lnTo>
-                  <a:lnTo>
-                    <a:pt x="289496" y="144754"/>
-                  </a:lnTo>
-                  <a:lnTo>
-                    <a:pt x="282116" y="99000"/>
-                  </a:lnTo>
-                  <a:lnTo>
-                    <a:pt x="261568" y="59264"/>
-                  </a:lnTo>
-                  <a:lnTo>
-                    <a:pt x="230235" y="27929"/>
-                  </a:lnTo>
-                  <a:lnTo>
-                    <a:pt x="190502" y="7379"/>
-                  </a:lnTo>
-                  <a:lnTo>
-                    <a:pt x="144754" y="0"/>
-                  </a:lnTo>
-                  <a:close/>
-                </a:path>
-              </a:pathLst>
-            </a:custGeom>
-            <a:solidFill>
-              <a:srgbClr val="214E85"/>
-            </a:solidFill>
-          </p:spPr>
-          <p:txBody>
-            <a:bodyPr wrap="square" lIns="0" tIns="0" rIns="0" bIns="0" rtlCol="0"/>
-            <a:lstStyle/>
-            <a:p>
-              <a:endParaRPr/>
-            </a:p>
-          </p:txBody>
-        </p:sp>
-        <p:sp>
-          <p:nvSpPr>
-            <p:cNvPr id="24" name="object 24">
-              <a:hlinkClick r:id="rId10"/>
-            </p:cNvPr>
-            <p:cNvSpPr/>
-            <p:nvPr/>
-          </p:nvSpPr>
-          <p:spPr>
-            <a:xfrm>
-              <a:off x="8142160" y="3441662"/>
-              <a:ext cx="289560" cy="289560"/>
-            </a:xfrm>
-            <a:custGeom>
-              <a:avLst/>
-              <a:gdLst/>
-              <a:ahLst/>
-              <a:cxnLst/>
-              <a:rect l="l" t="t" r="r" b="b"/>
-              <a:pathLst>
-                <a:path w="289559" h="289560">
-                  <a:moveTo>
-                    <a:pt x="144754" y="0"/>
-                  </a:moveTo>
-                  <a:lnTo>
-                    <a:pt x="190502" y="7379"/>
-                  </a:lnTo>
-                  <a:lnTo>
-                    <a:pt x="230235" y="27929"/>
-                  </a:lnTo>
-                  <a:lnTo>
-                    <a:pt x="261568" y="59264"/>
-                  </a:lnTo>
-                  <a:lnTo>
-                    <a:pt x="282116" y="99000"/>
-                  </a:lnTo>
-                  <a:lnTo>
-                    <a:pt x="289496" y="144754"/>
-                  </a:lnTo>
-                  <a:lnTo>
-                    <a:pt x="282116" y="190502"/>
-                  </a:lnTo>
-                  <a:lnTo>
-                    <a:pt x="261568" y="230235"/>
-                  </a:lnTo>
-                  <a:lnTo>
-                    <a:pt x="230235" y="261568"/>
-                  </a:lnTo>
-                  <a:lnTo>
-                    <a:pt x="190502" y="282116"/>
-                  </a:lnTo>
-                  <a:lnTo>
-                    <a:pt x="144754" y="289496"/>
-                  </a:lnTo>
-                  <a:lnTo>
-                    <a:pt x="99000" y="282116"/>
-                  </a:lnTo>
-                  <a:lnTo>
-                    <a:pt x="59264" y="261568"/>
-                  </a:lnTo>
-                  <a:lnTo>
-                    <a:pt x="27929" y="230235"/>
-                  </a:lnTo>
-                  <a:lnTo>
-                    <a:pt x="7379" y="190502"/>
-                  </a:lnTo>
-                  <a:lnTo>
-                    <a:pt x="0" y="144754"/>
-                  </a:lnTo>
-                  <a:lnTo>
-                    <a:pt x="7379" y="99000"/>
-                  </a:lnTo>
-                  <a:lnTo>
-                    <a:pt x="27929" y="59264"/>
-                  </a:lnTo>
-                  <a:lnTo>
-                    <a:pt x="59264" y="27929"/>
-                  </a:lnTo>
-                  <a:lnTo>
-                    <a:pt x="99000" y="7379"/>
-                  </a:lnTo>
-                  <a:lnTo>
-                    <a:pt x="144754" y="0"/>
-                  </a:lnTo>
-                  <a:close/>
-                </a:path>
-              </a:pathLst>
-            </a:custGeom>
-            <a:ln w="15405">
-              <a:solidFill>
-                <a:srgbClr val="FFFFFF"/>
-              </a:solidFill>
-            </a:ln>
-          </p:spPr>
-          <p:txBody>
-            <a:bodyPr wrap="square" lIns="0" tIns="0" rIns="0" bIns="0" rtlCol="0"/>
-            <a:lstStyle/>
-            <a:p>
-              <a:endParaRPr/>
-            </a:p>
-          </p:txBody>
-        </p:sp>
-        <p:pic>
-          <p:nvPicPr>
-            <p:cNvPr id="25" name="object 25">
-              <a:hlinkClick r:id="rId10"/>
-            </p:cNvPr>
-            <p:cNvPicPr/>
-            <p:nvPr/>
-          </p:nvPicPr>
-          <p:blipFill>
-            <a:blip r:embed="rId11" cstate="print"/>
-            <a:stretch>
-              <a:fillRect/>
-            </a:stretch>
-          </p:blipFill>
-          <p:spPr>
-            <a:xfrm>
-              <a:off x="8197595" y="3534054"/>
-              <a:ext cx="181711" cy="115493"/>
-            </a:xfrm>
-            <a:prstGeom prst="rect">
-              <a:avLst/>
-            </a:prstGeom>
-          </p:spPr>
-        </p:pic>
-        <p:pic>
-          <p:nvPicPr>
-            <p:cNvPr id="26" name="object 26"/>
-            <p:cNvPicPr/>
-            <p:nvPr/>
-          </p:nvPicPr>
-          <p:blipFill>
-            <a:blip r:embed="rId12" cstate="print"/>
-            <a:stretch>
-              <a:fillRect/>
-            </a:stretch>
-          </p:blipFill>
-          <p:spPr>
-            <a:xfrm>
-              <a:off x="8460003" y="3433966"/>
-              <a:ext cx="899998" cy="899998"/>
-            </a:xfrm>
-            <a:prstGeom prst="rect">
-              <a:avLst/>
-            </a:prstGeom>
-          </p:spPr>
-        </p:pic>
-      </p:grpSp>
       <p:sp>
         <p:nvSpPr>
           <p:cNvPr id="27" name="object 27"/>
@@ -18701,7 +17952,7 @@
                 </a:solidFill>
                 <a:latin typeface="Century Gothic"/>
                 <a:cs typeface="Century Gothic"/>
-                <a:hlinkClick r:id="rId13"/>
+                <a:hlinkClick r:id="rId7"/>
               </a:rPr>
               <a:t>Тарифы</a:t>
             </a:r>
@@ -19088,26 +18339,121 @@
           </a:p>
         </p:txBody>
       </p:sp>
+      <p:sp>
+        <p:nvSpPr>
+          <p:cNvPr id="1026" name="AutoShape 2" descr="blob:https://web.telegram.org/d5f09edc-ace3-4855-b877-aa1b5dba9862"/>
+          <p:cNvSpPr>
+            <a:spLocks noChangeAspect="1" noChangeArrowheads="1"/>
+          </p:cNvSpPr>
+          <p:nvPr/>
+        </p:nvSpPr>
+        <p:spPr bwMode="auto">
+          <a:xfrm>
+            <a:off x="155575" y="-144463"/>
+            <a:ext cx="304800" cy="304801"/>
+          </a:xfrm>
+          <a:prstGeom prst="rect">
+            <a:avLst/>
+          </a:prstGeom>
+          <a:noFill/>
+        </p:spPr>
+        <p:txBody>
+          <a:bodyPr vert="horz" wrap="square" lIns="91440" tIns="45720" rIns="91440" bIns="45720" numCol="1" anchor="t" anchorCtr="0" compatLnSpc="1">
+            <a:prstTxWarp prst="textNoShape">
+              <a:avLst/>
+            </a:prstTxWarp>
+          </a:bodyPr>
+          <a:lstStyle/>
+          <a:p>
+            <a:endParaRPr lang="ru-RU"/>
+          </a:p>
+        </p:txBody>
+      </p:sp>
+      <p:sp>
+        <p:nvSpPr>
+          <p:cNvPr id="1028" name="AutoShape 4" descr="blob:https://web.telegram.org/d5f09edc-ace3-4855-b877-aa1b5dba9862"/>
+          <p:cNvSpPr>
+            <a:spLocks noChangeAspect="1" noChangeArrowheads="1"/>
+          </p:cNvSpPr>
+          <p:nvPr/>
+        </p:nvSpPr>
+        <p:spPr bwMode="auto">
+          <a:xfrm>
+            <a:off x="155575" y="-144463"/>
+            <a:ext cx="304800" cy="304801"/>
+          </a:xfrm>
+          <a:prstGeom prst="rect">
+            <a:avLst/>
+          </a:prstGeom>
+          <a:noFill/>
+        </p:spPr>
+        <p:txBody>
+          <a:bodyPr vert="horz" wrap="square" lIns="91440" tIns="45720" rIns="91440" bIns="45720" numCol="1" anchor="t" anchorCtr="0" compatLnSpc="1">
+            <a:prstTxWarp prst="textNoShape">
+              <a:avLst/>
+            </a:prstTxWarp>
+          </a:bodyPr>
+          <a:lstStyle/>
+          <a:p>
+            <a:endParaRPr lang="ru-RU"/>
+          </a:p>
+        </p:txBody>
+      </p:sp>
       <p:pic>
         <p:nvPicPr>
-          <p:cNvPr id="35" name="object 7"/>
-          <p:cNvPicPr/>
+          <p:cNvPr id="39" name="Рисунок 38" descr="Вострикова.png"/>
+          <p:cNvPicPr>
+            <a:picLocks noChangeAspect="1"/>
+          </p:cNvPicPr>
           <p:nvPr/>
         </p:nvPicPr>
         <p:blipFill>
-          <a:blip r:embed="rId14" cstate="print"/>
+          <a:blip r:embed="rId8" cstate="print"/>
           <a:stretch>
             <a:fillRect/>
           </a:stretch>
         </p:blipFill>
         <p:spPr>
           <a:xfrm>
-            <a:off x="3780002" y="1712798"/>
-            <a:ext cx="1511998" cy="1511998"/>
+            <a:off x="3746500" y="1647825"/>
+            <a:ext cx="1514900" cy="1519649"/>
           </a:xfrm>
           <a:prstGeom prst="rect">
             <a:avLst/>
           </a:prstGeom>
+        </p:spPr>
+      </p:pic>
+      <p:pic>
+        <p:nvPicPr>
+          <p:cNvPr id="40" name="Picture 5"/>
+          <p:cNvPicPr>
+            <a:picLocks noChangeAspect="1" noChangeArrowheads="1"/>
+          </p:cNvPicPr>
+          <p:nvPr/>
+        </p:nvPicPr>
+        <p:blipFill>
+          <a:blip r:embed="rId9" cstate="print"/>
+          <a:srcRect/>
+          <a:stretch>
+            <a:fillRect/>
+          </a:stretch>
+        </p:blipFill>
+        <p:spPr bwMode="auto">
+          <a:xfrm>
+            <a:off x="8013700" y="3781425"/>
+            <a:ext cx="762000" cy="751217"/>
+          </a:xfrm>
+          <a:prstGeom prst="rect">
+            <a:avLst/>
+          </a:prstGeom>
+          <a:noFill/>
+          <a:ln w="9525">
+            <a:noFill/>
+            <a:miter lim="800000"/>
+            <a:headEnd/>
+            <a:tailEnd/>
+          </a:ln>
+          <a:effectLst/>
         </p:spPr>
       </p:pic>
     </p:spTree>

</xml_diff>